<commit_message>
docs(image): update branding assets
</commit_message>
<xml_diff>
--- a/docs/image/ChatCargo.pptx
+++ b/docs/image/ChatCargo.pptx
@@ -6,6 +6,7 @@
   </p:sldMasterIdLst>
   <p:sldIdLst>
     <p:sldId id="256" r:id="rId2"/>
+    <p:sldId id="257" r:id="rId3"/>
   </p:sldIdLst>
   <p:sldSz cx="12192000" cy="1828800"/>
   <p:notesSz cx="6858000" cy="9144000"/>
@@ -163,7 +164,7 @@
           <a:p>
             <a:fld id="{E69B9EE9-F3BF-4B40-83E7-C9BC68FDDB0E}" type="datetimeFigureOut">
               <a:rPr lang="en-US" smtClean="0"/>
-              <a:t>5/1/2026</a:t>
+              <a:t>5/2/2026</a:t>
             </a:fld>
             <a:endParaRPr lang="en-US"/>
           </a:p>
@@ -316,7 +317,7 @@
           <a:p>
             <a:fld id="{E69B9EE9-F3BF-4B40-83E7-C9BC68FDDB0E}" type="datetimeFigureOut">
               <a:rPr lang="en-US" smtClean="0"/>
-              <a:t>5/1/2026</a:t>
+              <a:t>5/2/2026</a:t>
             </a:fld>
             <a:endParaRPr lang="en-US"/>
           </a:p>
@@ -548,7 +549,7 @@
           <a:p>
             <a:fld id="{E69B9EE9-F3BF-4B40-83E7-C9BC68FDDB0E}" type="datetimeFigureOut">
               <a:rPr lang="en-US" smtClean="0"/>
-              <a:t>5/1/2026</a:t>
+              <a:t>5/2/2026</a:t>
             </a:fld>
             <a:endParaRPr lang="en-US"/>
           </a:p>
@@ -851,7 +852,7 @@
           <a:p>
             <a:fld id="{E69B9EE9-F3BF-4B40-83E7-C9BC68FDDB0E}" type="datetimeFigureOut">
               <a:rPr lang="en-US" smtClean="0"/>
-              <a:t>5/1/2026</a:t>
+              <a:t>5/2/2026</a:t>
             </a:fld>
             <a:endParaRPr lang="en-US"/>
           </a:p>
@@ -1061,7 +1062,7 @@
           <a:p>
             <a:fld id="{E69B9EE9-F3BF-4B40-83E7-C9BC68FDDB0E}" type="datetimeFigureOut">
               <a:rPr lang="en-US" smtClean="0"/>
-              <a:t>5/1/2026</a:t>
+              <a:t>5/2/2026</a:t>
             </a:fld>
             <a:endParaRPr lang="en-US"/>
           </a:p>
@@ -1170,10 +1171,10 @@
       </p:grpSpPr>
       <p:sp>
         <p:nvSpPr>
-          <p:cNvPr id="18" name="9Slide.vn - 2019">
+          <p:cNvPr id="9" name="9Slide.vn - 2019">
             <a:extLst>
               <a:ext uri="{FF2B5EF4-FFF2-40B4-BE49-F238E27FC236}">
-                <a16:creationId xmlns:a16="http://schemas.microsoft.com/office/drawing/2014/main" id="{4064B936-EFDE-6F75-95CB-DA01EEDDD056}"/>
+                <a16:creationId xmlns:a16="http://schemas.microsoft.com/office/drawing/2014/main" id="{59CD79BA-6CB7-7282-556E-1E1A058D90D1}"/>
               </a:ext>
             </a:extLst>
           </p:cNvPr>
@@ -1354,7 +1355,7 @@
           <a:p>
             <a:fld id="{E69B9EE9-F3BF-4B40-83E7-C9BC68FDDB0E}" type="datetimeFigureOut">
               <a:rPr lang="en-US" smtClean="0"/>
-              <a:t>5/1/2026</a:t>
+              <a:t>5/2/2026</a:t>
             </a:fld>
             <a:endParaRPr lang="en-US"/>
           </a:p>
@@ -3003,8 +3004,8 @@
         </p:nvSpPr>
         <p:spPr>
           <a:xfrm>
-            <a:off x="4693550" y="114300"/>
-            <a:ext cx="4751300" cy="1231105"/>
+            <a:off x="2868817" y="189996"/>
+            <a:ext cx="5228997" cy="1354217"/>
           </a:xfrm>
           <a:prstGeom prst="rect">
             <a:avLst/>
@@ -3019,7 +3020,7 @@
           <a:p>
             <a:pPr algn="ctr"/>
             <a:r>
-              <a:rPr lang="en-US" sz="8000">
+              <a:rPr lang="en-US" sz="8800">
                 <a:solidFill>
                   <a:sysClr val="windowText" lastClr="000000"/>
                 </a:solidFill>
@@ -3044,8 +3045,8 @@
         </p:nvSpPr>
         <p:spPr>
           <a:xfrm>
-            <a:off x="4747250" y="1320974"/>
-            <a:ext cx="4643901" cy="307776"/>
+            <a:off x="8230116" y="649700"/>
+            <a:ext cx="3068148" cy="677108"/>
           </a:xfrm>
           <a:prstGeom prst="rect">
             <a:avLst/>
@@ -3059,23 +3060,34 @@
           <a:lstStyle/>
           <a:p>
             <a:r>
-              <a:rPr lang="en-US" sz="2000">
+              <a:rPr lang="en-US" sz="2200">
                 <a:solidFill>
                   <a:sysClr val="windowText" lastClr="000000"/>
                 </a:solidFill>
                 <a:latin typeface="#9Slide03 SFU Toledo Bold" panose="00000700000000000000" pitchFamily="2" charset="0"/>
               </a:rPr>
-              <a:t>Pack every chat. Preserve the knowledge</a:t>
+              <a:t>Pack every chat</a:t>
+            </a:r>
+          </a:p>
+          <a:p>
+            <a:r>
+              <a:rPr lang="en-US" sz="2200">
+                <a:solidFill>
+                  <a:sysClr val="windowText" lastClr="000000"/>
+                </a:solidFill>
+                <a:latin typeface="#9Slide03 SFU Toledo Bold" panose="00000700000000000000" pitchFamily="2" charset="0"/>
+              </a:rPr>
+              <a:t>Preserve the knowledge</a:t>
             </a:r>
           </a:p>
         </p:txBody>
       </p:sp>
       <p:grpSp>
         <p:nvGrpSpPr>
-          <p:cNvPr id="9" name="Graphic 6">
+          <p:cNvPr id="8" name="Group 7">
             <a:extLst>
               <a:ext uri="{FF2B5EF4-FFF2-40B4-BE49-F238E27FC236}">
-                <a16:creationId xmlns:a16="http://schemas.microsoft.com/office/drawing/2014/main" id="{EDDF1124-4A90-4F6E-C9C2-266D813B4806}"/>
+                <a16:creationId xmlns:a16="http://schemas.microsoft.com/office/drawing/2014/main" id="{14CB8BD3-62C3-DF54-6386-0D9F157BF022}"/>
               </a:ext>
             </a:extLst>
           </p:cNvPr>
@@ -3084,18 +3096,18 @@
         </p:nvGrpSpPr>
         <p:grpSpPr>
           <a:xfrm>
-            <a:off x="2747149" y="138564"/>
+            <a:off x="893737" y="129753"/>
             <a:ext cx="1740985" cy="1569294"/>
-            <a:chOff x="2998296" y="2656245"/>
-            <a:chExt cx="1713456" cy="1544482"/>
+            <a:chOff x="2529261" y="138564"/>
+            <a:chExt cx="1740985" cy="1569294"/>
           </a:xfrm>
         </p:grpSpPr>
         <p:grpSp>
           <p:nvGrpSpPr>
-            <p:cNvPr id="10" name="Graphic 6">
+            <p:cNvPr id="9" name="Graphic 6">
               <a:extLst>
                 <a:ext uri="{FF2B5EF4-FFF2-40B4-BE49-F238E27FC236}">
-                  <a16:creationId xmlns:a16="http://schemas.microsoft.com/office/drawing/2014/main" id="{25E8D84F-A053-5F1C-C859-E29BC92A9F54}"/>
+                  <a16:creationId xmlns:a16="http://schemas.microsoft.com/office/drawing/2014/main" id="{EDDF1124-4A90-4F6E-C9C2-266D813B4806}"/>
                 </a:ext>
               </a:extLst>
             </p:cNvPr>
@@ -3104,18 +3116,18 @@
           </p:nvGrpSpPr>
           <p:grpSpPr>
             <a:xfrm>
-              <a:off x="2998296" y="2656245"/>
-              <a:ext cx="1713456" cy="1544482"/>
+              <a:off x="2529261" y="138564"/>
+              <a:ext cx="1740985" cy="1569294"/>
               <a:chOff x="2998296" y="2656245"/>
               <a:chExt cx="1713456" cy="1544482"/>
             </a:xfrm>
           </p:grpSpPr>
           <p:grpSp>
             <p:nvGrpSpPr>
-              <p:cNvPr id="11" name="Graphic 6">
+              <p:cNvPr id="10" name="Graphic 6">
                 <a:extLst>
                   <a:ext uri="{FF2B5EF4-FFF2-40B4-BE49-F238E27FC236}">
-                    <a16:creationId xmlns:a16="http://schemas.microsoft.com/office/drawing/2014/main" id="{41B0B43D-38FF-392A-79CD-DF20AE9FB2BE}"/>
+                    <a16:creationId xmlns:a16="http://schemas.microsoft.com/office/drawing/2014/main" id="{25E8D84F-A053-5F1C-C859-E29BC92A9F54}"/>
                   </a:ext>
                 </a:extLst>
               </p:cNvPr>
@@ -3124,18 +3136,207 @@
             </p:nvGrpSpPr>
             <p:grpSpPr>
               <a:xfrm>
-                <a:off x="2998296" y="2945286"/>
-                <a:ext cx="1713456" cy="1255441"/>
-                <a:chOff x="2998296" y="2945286"/>
-                <a:chExt cx="1713456" cy="1255441"/>
+                <a:off x="2998296" y="2656245"/>
+                <a:ext cx="1713456" cy="1544482"/>
+                <a:chOff x="2998296" y="2656245"/>
+                <a:chExt cx="1713456" cy="1544482"/>
               </a:xfrm>
             </p:grpSpPr>
+            <p:grpSp>
+              <p:nvGrpSpPr>
+                <p:cNvPr id="11" name="Graphic 6">
+                  <a:extLst>
+                    <a:ext uri="{FF2B5EF4-FFF2-40B4-BE49-F238E27FC236}">
+                      <a16:creationId xmlns:a16="http://schemas.microsoft.com/office/drawing/2014/main" id="{41B0B43D-38FF-392A-79CD-DF20AE9FB2BE}"/>
+                    </a:ext>
+                  </a:extLst>
+                </p:cNvPr>
+                <p:cNvGrpSpPr/>
+                <p:nvPr/>
+              </p:nvGrpSpPr>
+              <p:grpSpPr>
+                <a:xfrm>
+                  <a:off x="2998296" y="2945286"/>
+                  <a:ext cx="1713456" cy="1255441"/>
+                  <a:chOff x="2998296" y="2945286"/>
+                  <a:chExt cx="1713456" cy="1255441"/>
+                </a:xfrm>
+              </p:grpSpPr>
+              <p:sp>
+                <p:nvSpPr>
+                  <p:cNvPr id="12" name="Freeform: Shape 11">
+                    <a:extLst>
+                      <a:ext uri="{FF2B5EF4-FFF2-40B4-BE49-F238E27FC236}">
+                        <a16:creationId xmlns:a16="http://schemas.microsoft.com/office/drawing/2014/main" id="{EDEA2C88-37F8-65B8-AAC1-7DE21F794ABD}"/>
+                      </a:ext>
+                    </a:extLst>
+                  </p:cNvPr>
+                  <p:cNvSpPr/>
+                  <p:nvPr/>
+                </p:nvSpPr>
+                <p:spPr>
+                  <a:xfrm>
+                    <a:off x="3805618" y="2960166"/>
+                    <a:ext cx="906134" cy="1240561"/>
+                  </a:xfrm>
+                  <a:custGeom>
+                    <a:avLst/>
+                    <a:gdLst>
+                      <a:gd name="csX0" fmla="*/ 906135 w 906134"/>
+                      <a:gd name="csY0" fmla="*/ 928956 h 1240561"/>
+                      <a:gd name="csX1" fmla="*/ 906100 w 906134"/>
+                      <a:gd name="csY1" fmla="*/ 16695 h 1240561"/>
+                      <a:gd name="csX2" fmla="*/ 0 w 906134"/>
+                      <a:gd name="csY2" fmla="*/ 0 h 1240561"/>
+                      <a:gd name="csX3" fmla="*/ 0 w 906134"/>
+                      <a:gd name="csY3" fmla="*/ 1240440 h 1240561"/>
+                      <a:gd name="csX4" fmla="*/ 294 w 906134"/>
+                      <a:gd name="csY4" fmla="*/ 1240562 h 1240561"/>
+                    </a:gdLst>
+                    <a:ahLst/>
+                    <a:cxnLst>
+                      <a:cxn ang="0">
+                        <a:pos x="csX0" y="csY0"/>
+                      </a:cxn>
+                      <a:cxn ang="0">
+                        <a:pos x="csX1" y="csY1"/>
+                      </a:cxn>
+                      <a:cxn ang="0">
+                        <a:pos x="csX2" y="csY2"/>
+                      </a:cxn>
+                      <a:cxn ang="0">
+                        <a:pos x="csX3" y="csY3"/>
+                      </a:cxn>
+                      <a:cxn ang="0">
+                        <a:pos x="csX4" y="csY4"/>
+                      </a:cxn>
+                    </a:cxnLst>
+                    <a:rect l="l" t="t" r="r" b="b"/>
+                    <a:pathLst>
+                      <a:path w="906134" h="1240561">
+                        <a:moveTo>
+                          <a:pt x="906135" y="928956"/>
+                        </a:moveTo>
+                        <a:lnTo>
+                          <a:pt x="906100" y="16695"/>
+                        </a:lnTo>
+                        <a:lnTo>
+                          <a:pt x="0" y="0"/>
+                        </a:lnTo>
+                        <a:lnTo>
+                          <a:pt x="0" y="1240440"/>
+                        </a:lnTo>
+                        <a:lnTo>
+                          <a:pt x="294" y="1240562"/>
+                        </a:lnTo>
+                        <a:close/>
+                      </a:path>
+                    </a:pathLst>
+                  </a:custGeom>
+                  <a:solidFill>
+                    <a:srgbClr val="EBCDAF"/>
+                  </a:solidFill>
+                  <a:ln w="4319" cap="flat">
+                    <a:noFill/>
+                    <a:prstDash val="solid"/>
+                    <a:miter/>
+                  </a:ln>
+                </p:spPr>
+                <p:txBody>
+                  <a:bodyPr/>
+                  <a:lstStyle/>
+                  <a:p>
+                    <a:endParaRPr lang="en-US" sz="2000"/>
+                  </a:p>
+                </p:txBody>
+              </p:sp>
+              <p:sp>
+                <p:nvSpPr>
+                  <p:cNvPr id="13" name="Freeform: Shape 12">
+                    <a:extLst>
+                      <a:ext uri="{FF2B5EF4-FFF2-40B4-BE49-F238E27FC236}">
+                        <a16:creationId xmlns:a16="http://schemas.microsoft.com/office/drawing/2014/main" id="{3907DF33-EC8B-BD0A-6824-7BB073E0A144}"/>
+                      </a:ext>
+                    </a:extLst>
+                  </p:cNvPr>
+                  <p:cNvSpPr/>
+                  <p:nvPr/>
+                </p:nvSpPr>
+                <p:spPr>
+                  <a:xfrm>
+                    <a:off x="2998296" y="2945286"/>
+                    <a:ext cx="807321" cy="1255320"/>
+                  </a:xfrm>
+                  <a:custGeom>
+                    <a:avLst/>
+                    <a:gdLst>
+                      <a:gd name="csX0" fmla="*/ 13 w 807321"/>
+                      <a:gd name="csY0" fmla="*/ 0 h 1255320"/>
+                      <a:gd name="csX1" fmla="*/ 0 w 807321"/>
+                      <a:gd name="csY1" fmla="*/ 912226 h 1255320"/>
+                      <a:gd name="csX2" fmla="*/ 807321 w 807321"/>
+                      <a:gd name="csY2" fmla="*/ 1255321 h 1255320"/>
+                      <a:gd name="csX3" fmla="*/ 807321 w 807321"/>
+                      <a:gd name="csY3" fmla="*/ 14881 h 1255320"/>
+                    </a:gdLst>
+                    <a:ahLst/>
+                    <a:cxnLst>
+                      <a:cxn ang="0">
+                        <a:pos x="csX0" y="csY0"/>
+                      </a:cxn>
+                      <a:cxn ang="0">
+                        <a:pos x="csX1" y="csY1"/>
+                      </a:cxn>
+                      <a:cxn ang="0">
+                        <a:pos x="csX2" y="csY2"/>
+                      </a:cxn>
+                      <a:cxn ang="0">
+                        <a:pos x="csX3" y="csY3"/>
+                      </a:cxn>
+                    </a:cxnLst>
+                    <a:rect l="l" t="t" r="r" b="b"/>
+                    <a:pathLst>
+                      <a:path w="807321" h="1255320">
+                        <a:moveTo>
+                          <a:pt x="13" y="0"/>
+                        </a:moveTo>
+                        <a:lnTo>
+                          <a:pt x="0" y="912226"/>
+                        </a:lnTo>
+                        <a:lnTo>
+                          <a:pt x="807321" y="1255321"/>
+                        </a:lnTo>
+                        <a:lnTo>
+                          <a:pt x="807321" y="14881"/>
+                        </a:lnTo>
+                        <a:close/>
+                      </a:path>
+                    </a:pathLst>
+                  </a:custGeom>
+                  <a:solidFill>
+                    <a:srgbClr val="C49772"/>
+                  </a:solidFill>
+                  <a:ln w="4319" cap="flat">
+                    <a:noFill/>
+                    <a:prstDash val="solid"/>
+                    <a:miter/>
+                  </a:ln>
+                </p:spPr>
+                <p:txBody>
+                  <a:bodyPr/>
+                  <a:lstStyle/>
+                  <a:p>
+                    <a:endParaRPr lang="en-US" sz="2000"/>
+                  </a:p>
+                </p:txBody>
+              </p:sp>
+            </p:grpSp>
             <p:sp>
               <p:nvSpPr>
-                <p:cNvPr id="12" name="Freeform: Shape 11">
+                <p:cNvPr id="14" name="Freeform: Shape 13">
                   <a:extLst>
                     <a:ext uri="{FF2B5EF4-FFF2-40B4-BE49-F238E27FC236}">
-                      <a16:creationId xmlns:a16="http://schemas.microsoft.com/office/drawing/2014/main" id="{EDEA2C88-37F8-65B8-AAC1-7DE21F794ABD}"/>
+                      <a16:creationId xmlns:a16="http://schemas.microsoft.com/office/drawing/2014/main" id="{969E3ECF-8F2C-0F57-748F-2DBEE17FFE07}"/>
                     </a:ext>
                   </a:extLst>
                 </p:cNvPr>
@@ -3144,22 +3345,42 @@
               </p:nvSpPr>
               <p:spPr>
                 <a:xfrm>
-                  <a:off x="3805618" y="2960166"/>
-                  <a:ext cx="906134" cy="1240561"/>
+                  <a:off x="3253315" y="2978385"/>
+                  <a:ext cx="269691" cy="628069"/>
                 </a:xfrm>
                 <a:custGeom>
                   <a:avLst/>
                   <a:gdLst>
-                    <a:gd name="csX0" fmla="*/ 906135 w 906134"/>
-                    <a:gd name="csY0" fmla="*/ 928956 h 1240561"/>
-                    <a:gd name="csX1" fmla="*/ 906100 w 906134"/>
-                    <a:gd name="csY1" fmla="*/ 16695 h 1240561"/>
-                    <a:gd name="csX2" fmla="*/ 0 w 906134"/>
-                    <a:gd name="csY2" fmla="*/ 0 h 1240561"/>
-                    <a:gd name="csX3" fmla="*/ 0 w 906134"/>
-                    <a:gd name="csY3" fmla="*/ 1240440 h 1240561"/>
-                    <a:gd name="csX4" fmla="*/ 294 w 906134"/>
-                    <a:gd name="csY4" fmla="*/ 1240562 h 1240561"/>
+                    <a:gd name="csX0" fmla="*/ 11781 w 269691"/>
+                    <a:gd name="csY0" fmla="*/ 0 h 628069"/>
+                    <a:gd name="csX1" fmla="*/ 0 w 269691"/>
+                    <a:gd name="csY1" fmla="*/ 75265 h 628069"/>
+                    <a:gd name="csX2" fmla="*/ 0 w 269691"/>
+                    <a:gd name="csY2" fmla="*/ 495391 h 628069"/>
+                    <a:gd name="csX3" fmla="*/ 34974 w 269691"/>
+                    <a:gd name="csY3" fmla="*/ 480843 h 628069"/>
+                    <a:gd name="csX4" fmla="*/ 47859 w 269691"/>
+                    <a:gd name="csY4" fmla="*/ 524174 h 628069"/>
+                    <a:gd name="csX5" fmla="*/ 89604 w 269691"/>
+                    <a:gd name="csY5" fmla="*/ 506816 h 628069"/>
+                    <a:gd name="csX6" fmla="*/ 102493 w 269691"/>
+                    <a:gd name="csY6" fmla="*/ 550146 h 628069"/>
+                    <a:gd name="csX7" fmla="*/ 144234 w 269691"/>
+                    <a:gd name="csY7" fmla="*/ 532789 h 628069"/>
+                    <a:gd name="csX8" fmla="*/ 157123 w 269691"/>
+                    <a:gd name="csY8" fmla="*/ 576124 h 628069"/>
+                    <a:gd name="csX9" fmla="*/ 198873 w 269691"/>
+                    <a:gd name="csY9" fmla="*/ 558771 h 628069"/>
+                    <a:gd name="csX10" fmla="*/ 211749 w 269691"/>
+                    <a:gd name="csY10" fmla="*/ 602097 h 628069"/>
+                    <a:gd name="csX11" fmla="*/ 253490 w 269691"/>
+                    <a:gd name="csY11" fmla="*/ 584740 h 628069"/>
+                    <a:gd name="csX12" fmla="*/ 266380 w 269691"/>
+                    <a:gd name="csY12" fmla="*/ 628070 h 628069"/>
+                    <a:gd name="csX13" fmla="*/ 268765 w 269691"/>
+                    <a:gd name="csY13" fmla="*/ 627078 h 628069"/>
+                    <a:gd name="csX14" fmla="*/ 269692 w 269691"/>
+                    <a:gd name="csY14" fmla="*/ 57314 h 628069"/>
                   </a:gdLst>
                   <a:ahLst/>
                   <a:cxnLst>
@@ -3178,31 +3399,91 @@
                     <a:cxn ang="0">
                       <a:pos x="csX4" y="csY4"/>
                     </a:cxn>
+                    <a:cxn ang="0">
+                      <a:pos x="csX5" y="csY5"/>
+                    </a:cxn>
+                    <a:cxn ang="0">
+                      <a:pos x="csX6" y="csY6"/>
+                    </a:cxn>
+                    <a:cxn ang="0">
+                      <a:pos x="csX7" y="csY7"/>
+                    </a:cxn>
+                    <a:cxn ang="0">
+                      <a:pos x="csX8" y="csY8"/>
+                    </a:cxn>
+                    <a:cxn ang="0">
+                      <a:pos x="csX9" y="csY9"/>
+                    </a:cxn>
+                    <a:cxn ang="0">
+                      <a:pos x="csX10" y="csY10"/>
+                    </a:cxn>
+                    <a:cxn ang="0">
+                      <a:pos x="csX11" y="csY11"/>
+                    </a:cxn>
+                    <a:cxn ang="0">
+                      <a:pos x="csX12" y="csY12"/>
+                    </a:cxn>
+                    <a:cxn ang="0">
+                      <a:pos x="csX13" y="csY13"/>
+                    </a:cxn>
+                    <a:cxn ang="0">
+                      <a:pos x="csX14" y="csY14"/>
+                    </a:cxn>
                   </a:cxnLst>
                   <a:rect l="l" t="t" r="r" b="b"/>
                   <a:pathLst>
-                    <a:path w="906134" h="1240561">
+                    <a:path w="269691" h="628069">
                       <a:moveTo>
-                        <a:pt x="906135" y="928956"/>
+                        <a:pt x="11781" y="0"/>
                       </a:moveTo>
                       <a:lnTo>
-                        <a:pt x="906100" y="16695"/>
+                        <a:pt x="0" y="75265"/>
                       </a:lnTo>
                       <a:lnTo>
-                        <a:pt x="0" y="0"/>
+                        <a:pt x="0" y="495391"/>
                       </a:lnTo>
                       <a:lnTo>
-                        <a:pt x="0" y="1240440"/>
+                        <a:pt x="34974" y="480843"/>
                       </a:lnTo>
                       <a:lnTo>
-                        <a:pt x="294" y="1240562"/>
+                        <a:pt x="47859" y="524174"/>
+                      </a:lnTo>
+                      <a:lnTo>
+                        <a:pt x="89604" y="506816"/>
+                      </a:lnTo>
+                      <a:lnTo>
+                        <a:pt x="102493" y="550146"/>
+                      </a:lnTo>
+                      <a:lnTo>
+                        <a:pt x="144234" y="532789"/>
+                      </a:lnTo>
+                      <a:lnTo>
+                        <a:pt x="157123" y="576124"/>
+                      </a:lnTo>
+                      <a:lnTo>
+                        <a:pt x="198873" y="558771"/>
+                      </a:lnTo>
+                      <a:lnTo>
+                        <a:pt x="211749" y="602097"/>
+                      </a:lnTo>
+                      <a:lnTo>
+                        <a:pt x="253490" y="584740"/>
+                      </a:lnTo>
+                      <a:lnTo>
+                        <a:pt x="266380" y="628070"/>
+                      </a:lnTo>
+                      <a:lnTo>
+                        <a:pt x="268765" y="627078"/>
+                      </a:lnTo>
+                      <a:lnTo>
+                        <a:pt x="269692" y="57314"/>
                       </a:lnTo>
                       <a:close/>
                     </a:path>
                   </a:pathLst>
                 </a:custGeom>
                 <a:solidFill>
-                  <a:srgbClr val="EBCDAF"/>
+                  <a:srgbClr val="DBB693"/>
                 </a:solidFill>
                 <a:ln w="4319" cap="flat">
                   <a:noFill/>
@@ -3220,10 +3501,10 @@
             </p:sp>
             <p:sp>
               <p:nvSpPr>
-                <p:cNvPr id="13" name="Freeform: Shape 12">
+                <p:cNvPr id="15" name="Freeform: Shape 14">
                   <a:extLst>
                     <a:ext uri="{FF2B5EF4-FFF2-40B4-BE49-F238E27FC236}">
-                      <a16:creationId xmlns:a16="http://schemas.microsoft.com/office/drawing/2014/main" id="{3907DF33-EC8B-BD0A-6824-7BB073E0A144}"/>
+                      <a16:creationId xmlns:a16="http://schemas.microsoft.com/office/drawing/2014/main" id="{DB7CE02E-3B3F-512B-93B0-5EEB081ED4E2}"/>
                     </a:ext>
                   </a:extLst>
                 </p:cNvPr>
@@ -3232,20 +3513,20 @@
               </p:nvSpPr>
               <p:spPr>
                 <a:xfrm>
-                  <a:off x="2998296" y="2945286"/>
-                  <a:ext cx="807321" cy="1255320"/>
+                  <a:off x="2998296" y="2656245"/>
+                  <a:ext cx="1713456" cy="632247"/>
                 </a:xfrm>
                 <a:custGeom>
                   <a:avLst/>
                   <a:gdLst>
-                    <a:gd name="csX0" fmla="*/ 13 w 807321"/>
-                    <a:gd name="csY0" fmla="*/ 0 h 1255320"/>
-                    <a:gd name="csX1" fmla="*/ 0 w 807321"/>
-                    <a:gd name="csY1" fmla="*/ 912226 h 1255320"/>
-                    <a:gd name="csX2" fmla="*/ 807321 w 807321"/>
-                    <a:gd name="csY2" fmla="*/ 1255321 h 1255320"/>
-                    <a:gd name="csX3" fmla="*/ 807321 w 807321"/>
-                    <a:gd name="csY3" fmla="*/ 14881 h 1255320"/>
+                    <a:gd name="csX0" fmla="*/ 0 w 1713456"/>
+                    <a:gd name="csY0" fmla="*/ 289027 h 632247"/>
+                    <a:gd name="csX1" fmla="*/ 927670 w 1713456"/>
+                    <a:gd name="csY1" fmla="*/ 0 h 632247"/>
+                    <a:gd name="csX2" fmla="*/ 1713456 w 1713456"/>
+                    <a:gd name="csY2" fmla="*/ 320642 h 632247"/>
+                    <a:gd name="csX3" fmla="*/ 807616 w 1713456"/>
+                    <a:gd name="csY3" fmla="*/ 632248 h 632247"/>
                   </a:gdLst>
                   <a:ahLst/>
                   <a:cxnLst>
@@ -3264,25 +3545,187 @@
                   </a:cxnLst>
                   <a:rect l="l" t="t" r="r" b="b"/>
                   <a:pathLst>
-                    <a:path w="807321" h="1255320">
+                    <a:path w="1713456" h="632247">
                       <a:moveTo>
-                        <a:pt x="13" y="0"/>
+                        <a:pt x="0" y="289027"/>
                       </a:moveTo>
                       <a:lnTo>
-                        <a:pt x="0" y="912226"/>
+                        <a:pt x="927670" y="0"/>
                       </a:lnTo>
                       <a:lnTo>
-                        <a:pt x="807321" y="1255321"/>
+                        <a:pt x="1713456" y="320642"/>
                       </a:lnTo>
                       <a:lnTo>
-                        <a:pt x="807321" y="14881"/>
+                        <a:pt x="807616" y="632248"/>
                       </a:lnTo>
                       <a:close/>
                     </a:path>
                   </a:pathLst>
                 </a:custGeom>
                 <a:solidFill>
-                  <a:srgbClr val="C49772"/>
+                  <a:srgbClr val="D09565"/>
+                </a:solidFill>
+                <a:ln w="4319" cap="flat">
+                  <a:noFill/>
+                  <a:prstDash val="solid"/>
+                  <a:miter/>
+                </a:ln>
+              </p:spPr>
+              <p:txBody>
+                <a:bodyPr/>
+                <a:lstStyle/>
+                <a:p>
+                  <a:endParaRPr lang="en-US" sz="2000"/>
+                </a:p>
+              </p:txBody>
+            </p:sp>
+            <p:sp>
+              <p:nvSpPr>
+                <p:cNvPr id="16" name="Freeform: Shape 15">
+                  <a:extLst>
+                    <a:ext uri="{FF2B5EF4-FFF2-40B4-BE49-F238E27FC236}">
+                      <a16:creationId xmlns:a16="http://schemas.microsoft.com/office/drawing/2014/main" id="{A2E30E63-4C38-1D62-3576-07CEB4335180}"/>
+                    </a:ext>
+                  </a:extLst>
+                </p:cNvPr>
+                <p:cNvSpPr/>
+                <p:nvPr/>
+              </p:nvSpPr>
+              <p:spPr>
+                <a:xfrm>
+                  <a:off x="3253315" y="2748759"/>
+                  <a:ext cx="1151693" cy="421225"/>
+                </a:xfrm>
+                <a:custGeom>
+                  <a:avLst/>
+                  <a:gdLst>
+                    <a:gd name="csX0" fmla="*/ 899368 w 1151693"/>
+                    <a:gd name="csY0" fmla="*/ 0 h 421225"/>
+                    <a:gd name="csX1" fmla="*/ 0 w 1151693"/>
+                    <a:gd name="csY1" fmla="*/ 304891 h 421225"/>
+                    <a:gd name="csX2" fmla="*/ 273744 w 1151693"/>
+                    <a:gd name="csY2" fmla="*/ 421226 h 421225"/>
+                    <a:gd name="csX3" fmla="*/ 1151693 w 1151693"/>
+                    <a:gd name="csY3" fmla="*/ 102961 h 421225"/>
+                  </a:gdLst>
+                  <a:ahLst/>
+                  <a:cxnLst>
+                    <a:cxn ang="0">
+                      <a:pos x="csX0" y="csY0"/>
+                    </a:cxn>
+                    <a:cxn ang="0">
+                      <a:pos x="csX1" y="csY1"/>
+                    </a:cxn>
+                    <a:cxn ang="0">
+                      <a:pos x="csX2" y="csY2"/>
+                    </a:cxn>
+                    <a:cxn ang="0">
+                      <a:pos x="csX3" y="csY3"/>
+                    </a:cxn>
+                  </a:cxnLst>
+                  <a:rect l="l" t="t" r="r" b="b"/>
+                  <a:pathLst>
+                    <a:path w="1151693" h="421225">
+                      <a:moveTo>
+                        <a:pt x="899368" y="0"/>
+                      </a:moveTo>
+                      <a:lnTo>
+                        <a:pt x="0" y="304891"/>
+                      </a:lnTo>
+                      <a:lnTo>
+                        <a:pt x="273744" y="421226"/>
+                      </a:lnTo>
+                      <a:lnTo>
+                        <a:pt x="1151693" y="102961"/>
+                      </a:lnTo>
+                      <a:close/>
+                    </a:path>
+                  </a:pathLst>
+                </a:custGeom>
+                <a:solidFill>
+                  <a:srgbClr val="F3DEB4"/>
+                </a:solidFill>
+                <a:ln w="4319" cap="flat">
+                  <a:noFill/>
+                  <a:prstDash val="solid"/>
+                  <a:miter/>
+                </a:ln>
+              </p:spPr>
+              <p:txBody>
+                <a:bodyPr/>
+                <a:lstStyle/>
+                <a:p>
+                  <a:endParaRPr lang="en-US" sz="2000"/>
+                </a:p>
+              </p:txBody>
+            </p:sp>
+            <p:sp>
+              <p:nvSpPr>
+                <p:cNvPr id="17" name="Freeform: Shape 16">
+                  <a:extLst>
+                    <a:ext uri="{FF2B5EF4-FFF2-40B4-BE49-F238E27FC236}">
+                      <a16:creationId xmlns:a16="http://schemas.microsoft.com/office/drawing/2014/main" id="{8E9B7BBC-80F3-9D68-57E8-7F7CEC8D8FAC}"/>
+                    </a:ext>
+                  </a:extLst>
+                </p:cNvPr>
+                <p:cNvSpPr/>
+                <p:nvPr/>
+              </p:nvSpPr>
+              <p:spPr>
+                <a:xfrm>
+                  <a:off x="2998296" y="2656245"/>
+                  <a:ext cx="1713456" cy="320641"/>
+                </a:xfrm>
+                <a:custGeom>
+                  <a:avLst/>
+                  <a:gdLst>
+                    <a:gd name="csX0" fmla="*/ 0 w 1713456"/>
+                    <a:gd name="csY0" fmla="*/ 289027 h 320641"/>
+                    <a:gd name="csX1" fmla="*/ 927670 w 1713456"/>
+                    <a:gd name="csY1" fmla="*/ 0 h 320641"/>
+                    <a:gd name="csX2" fmla="*/ 1713456 w 1713456"/>
+                    <a:gd name="csY2" fmla="*/ 320642 h 320641"/>
+                    <a:gd name="csX3" fmla="*/ 933805 w 1713456"/>
+                    <a:gd name="csY3" fmla="*/ 32610 h 320641"/>
+                  </a:gdLst>
+                  <a:ahLst/>
+                  <a:cxnLst>
+                    <a:cxn ang="0">
+                      <a:pos x="csX0" y="csY0"/>
+                    </a:cxn>
+                    <a:cxn ang="0">
+                      <a:pos x="csX1" y="csY1"/>
+                    </a:cxn>
+                    <a:cxn ang="0">
+                      <a:pos x="csX2" y="csY2"/>
+                    </a:cxn>
+                    <a:cxn ang="0">
+                      <a:pos x="csX3" y="csY3"/>
+                    </a:cxn>
+                  </a:cxnLst>
+                  <a:rect l="l" t="t" r="r" b="b"/>
+                  <a:pathLst>
+                    <a:path w="1713456" h="320641">
+                      <a:moveTo>
+                        <a:pt x="0" y="289027"/>
+                      </a:moveTo>
+                      <a:lnTo>
+                        <a:pt x="927670" y="0"/>
+                      </a:lnTo>
+                      <a:lnTo>
+                        <a:pt x="1713456" y="320642"/>
+                      </a:lnTo>
+                      <a:lnTo>
+                        <a:pt x="933805" y="32610"/>
+                      </a:lnTo>
+                      <a:close/>
+                    </a:path>
+                  </a:pathLst>
+                </a:custGeom>
+                <a:solidFill>
+                  <a:srgbClr val="E5BE97">
+                    <a:alpha val="52000"/>
+                  </a:srgbClr>
                 </a:solidFill>
                 <a:ln w="4319" cap="flat">
                   <a:noFill/>
@@ -3301,10 +3744,10 @@
           </p:grpSp>
           <p:sp>
             <p:nvSpPr>
-              <p:cNvPr id="14" name="Freeform: Shape 13">
+              <p:cNvPr id="18" name="Freeform: Shape 17">
                 <a:extLst>
                   <a:ext uri="{FF2B5EF4-FFF2-40B4-BE49-F238E27FC236}">
-                    <a16:creationId xmlns:a16="http://schemas.microsoft.com/office/drawing/2014/main" id="{969E3ECF-8F2C-0F57-748F-2DBEE17FFE07}"/>
+                    <a16:creationId xmlns:a16="http://schemas.microsoft.com/office/drawing/2014/main" id="{ADD56887-5F39-E9D3-57AE-08202AF25066}"/>
                   </a:ext>
                 </a:extLst>
               </p:cNvPr>
@@ -3313,42 +3756,36 @@
             </p:nvSpPr>
             <p:spPr>
               <a:xfrm>
-                <a:off x="3253315" y="2978385"/>
-                <a:ext cx="269691" cy="628069"/>
+                <a:off x="3033801" y="3025729"/>
+                <a:ext cx="147679" cy="648615"/>
               </a:xfrm>
               <a:custGeom>
                 <a:avLst/>
                 <a:gdLst>
-                  <a:gd name="csX0" fmla="*/ 11781 w 269691"/>
-                  <a:gd name="csY0" fmla="*/ 0 h 628069"/>
-                  <a:gd name="csX1" fmla="*/ 0 w 269691"/>
-                  <a:gd name="csY1" fmla="*/ 75265 h 628069"/>
-                  <a:gd name="csX2" fmla="*/ 0 w 269691"/>
-                  <a:gd name="csY2" fmla="*/ 495391 h 628069"/>
-                  <a:gd name="csX3" fmla="*/ 34974 w 269691"/>
-                  <a:gd name="csY3" fmla="*/ 480843 h 628069"/>
-                  <a:gd name="csX4" fmla="*/ 47859 w 269691"/>
-                  <a:gd name="csY4" fmla="*/ 524174 h 628069"/>
-                  <a:gd name="csX5" fmla="*/ 89604 w 269691"/>
-                  <a:gd name="csY5" fmla="*/ 506816 h 628069"/>
-                  <a:gd name="csX6" fmla="*/ 102493 w 269691"/>
-                  <a:gd name="csY6" fmla="*/ 550146 h 628069"/>
-                  <a:gd name="csX7" fmla="*/ 144234 w 269691"/>
-                  <a:gd name="csY7" fmla="*/ 532789 h 628069"/>
-                  <a:gd name="csX8" fmla="*/ 157123 w 269691"/>
-                  <a:gd name="csY8" fmla="*/ 576124 h 628069"/>
-                  <a:gd name="csX9" fmla="*/ 198873 w 269691"/>
-                  <a:gd name="csY9" fmla="*/ 558771 h 628069"/>
-                  <a:gd name="csX10" fmla="*/ 211749 w 269691"/>
-                  <a:gd name="csY10" fmla="*/ 602097 h 628069"/>
-                  <a:gd name="csX11" fmla="*/ 253490 w 269691"/>
-                  <a:gd name="csY11" fmla="*/ 584740 h 628069"/>
-                  <a:gd name="csX12" fmla="*/ 266380 w 269691"/>
-                  <a:gd name="csY12" fmla="*/ 628070 h 628069"/>
-                  <a:gd name="csX13" fmla="*/ 268765 w 269691"/>
-                  <a:gd name="csY13" fmla="*/ 627078 h 628069"/>
-                  <a:gd name="csX14" fmla="*/ 269692 w 269691"/>
-                  <a:gd name="csY14" fmla="*/ 57314 h 628069"/>
+                  <a:gd name="csX0" fmla="*/ 146791 w 147679"/>
+                  <a:gd name="csY0" fmla="*/ 224308 h 648615"/>
+                  <a:gd name="csX1" fmla="*/ 128689 w 147679"/>
+                  <a:gd name="csY1" fmla="*/ 119256 h 648615"/>
+                  <a:gd name="csX2" fmla="*/ 74310 w 147679"/>
+                  <a:gd name="csY2" fmla="*/ 21720 h 648615"/>
+                  <a:gd name="csX3" fmla="*/ 11254 w 147679"/>
+                  <a:gd name="csY3" fmla="*/ 27020 h 648615"/>
+                  <a:gd name="csX4" fmla="*/ 1197 w 147679"/>
+                  <a:gd name="csY4" fmla="*/ 203670 h 648615"/>
+                  <a:gd name="csX5" fmla="*/ 1764 w 147679"/>
+                  <a:gd name="csY5" fmla="*/ 576859 h 648615"/>
+                  <a:gd name="csX6" fmla="*/ 6665 w 147679"/>
+                  <a:gd name="csY6" fmla="*/ 616574 h 648615"/>
+                  <a:gd name="csX7" fmla="*/ 54173 w 147679"/>
+                  <a:gd name="csY7" fmla="*/ 640460 h 648615"/>
+                  <a:gd name="csX8" fmla="*/ 81839 w 147679"/>
+                  <a:gd name="csY8" fmla="*/ 600905 h 648615"/>
+                  <a:gd name="csX9" fmla="*/ 115523 w 147679"/>
+                  <a:gd name="csY9" fmla="*/ 514847 h 648615"/>
+                  <a:gd name="csX10" fmla="*/ 146843 w 147679"/>
+                  <a:gd name="csY10" fmla="*/ 225174 h 648615"/>
+                  <a:gd name="csX11" fmla="*/ 146791 w 147679"/>
+                  <a:gd name="csY11" fmla="*/ 224308 h 648615"/>
                 </a:gdLst>
                 <a:ahLst/>
                 <a:cxnLst>
@@ -3388,70 +3825,74 @@
                   <a:cxn ang="0">
                     <a:pos x="csX11" y="csY11"/>
                   </a:cxn>
-                  <a:cxn ang="0">
-                    <a:pos x="csX12" y="csY12"/>
-                  </a:cxn>
-                  <a:cxn ang="0">
-                    <a:pos x="csX13" y="csY13"/>
-                  </a:cxn>
-                  <a:cxn ang="0">
-                    <a:pos x="csX14" y="csY14"/>
-                  </a:cxn>
                 </a:cxnLst>
                 <a:rect l="l" t="t" r="r" b="b"/>
                 <a:pathLst>
-                  <a:path w="269691" h="628069">
+                  <a:path w="147679" h="648615">
                     <a:moveTo>
-                      <a:pt x="11781" y="0"/>
+                      <a:pt x="146791" y="224308"/>
                     </a:moveTo>
+                    <a:cubicBezTo>
+                      <a:pt x="144760" y="188984"/>
+                      <a:pt x="139552" y="153282"/>
+                      <a:pt x="128689" y="119256"/>
+                    </a:cubicBezTo>
+                    <a:cubicBezTo>
+                      <a:pt x="117194" y="83235"/>
+                      <a:pt x="99209" y="48793"/>
+                      <a:pt x="74310" y="21720"/>
+                    </a:cubicBezTo>
+                    <a:cubicBezTo>
+                      <a:pt x="53654" y="-1473"/>
+                      <a:pt x="21104" y="-14544"/>
+                      <a:pt x="11254" y="27020"/>
+                    </a:cubicBezTo>
+                    <a:cubicBezTo>
+                      <a:pt x="1478" y="84733"/>
+                      <a:pt x="3007" y="145073"/>
+                      <a:pt x="1197" y="203670"/>
+                    </a:cubicBezTo>
+                    <a:cubicBezTo>
+                      <a:pt x="123" y="328187"/>
+                      <a:pt x="-1085" y="452705"/>
+                      <a:pt x="1764" y="576859"/>
+                    </a:cubicBezTo>
+                    <a:cubicBezTo>
+                      <a:pt x="2461" y="590376"/>
+                      <a:pt x="3526" y="604222"/>
+                      <a:pt x="6665" y="616574"/>
+                    </a:cubicBezTo>
+                    <a:cubicBezTo>
+                      <a:pt x="12302" y="642967"/>
+                      <a:pt x="32807" y="659341"/>
+                      <a:pt x="54173" y="640460"/>
+                    </a:cubicBezTo>
+                    <a:cubicBezTo>
+                      <a:pt x="66331" y="630173"/>
+                      <a:pt x="74708" y="615167"/>
+                      <a:pt x="81839" y="600905"/>
+                    </a:cubicBezTo>
+                    <a:cubicBezTo>
+                      <a:pt x="95248" y="573378"/>
+                      <a:pt x="106426" y="544431"/>
+                      <a:pt x="115523" y="514847"/>
+                    </a:cubicBezTo>
+                    <a:cubicBezTo>
+                      <a:pt x="143383" y="421580"/>
+                      <a:pt x="150350" y="321974"/>
+                      <a:pt x="146843" y="225174"/>
+                    </a:cubicBezTo>
                     <a:lnTo>
-                      <a:pt x="0" y="75265"/>
-                    </a:lnTo>
-                    <a:lnTo>
-                      <a:pt x="0" y="495391"/>
-                    </a:lnTo>
-                    <a:lnTo>
-                      <a:pt x="34974" y="480843"/>
-                    </a:lnTo>
-                    <a:lnTo>
-                      <a:pt x="47859" y="524174"/>
-                    </a:lnTo>
-                    <a:lnTo>
-                      <a:pt x="89604" y="506816"/>
-                    </a:lnTo>
-                    <a:lnTo>
-                      <a:pt x="102493" y="550146"/>
-                    </a:lnTo>
-                    <a:lnTo>
-                      <a:pt x="144234" y="532789"/>
-                    </a:lnTo>
-                    <a:lnTo>
-                      <a:pt x="157123" y="576124"/>
-                    </a:lnTo>
-                    <a:lnTo>
-                      <a:pt x="198873" y="558771"/>
-                    </a:lnTo>
-                    <a:lnTo>
-                      <a:pt x="211749" y="602097"/>
-                    </a:lnTo>
-                    <a:lnTo>
-                      <a:pt x="253490" y="584740"/>
-                    </a:lnTo>
-                    <a:lnTo>
-                      <a:pt x="266380" y="628070"/>
-                    </a:lnTo>
-                    <a:lnTo>
-                      <a:pt x="268765" y="627078"/>
-                    </a:lnTo>
-                    <a:lnTo>
-                      <a:pt x="269692" y="57314"/>
+                      <a:pt x="146791" y="224308"/>
                     </a:lnTo>
                     <a:close/>
                   </a:path>
                 </a:pathLst>
               </a:custGeom>
               <a:solidFill>
-                <a:srgbClr val="DBB693"/>
+                <a:srgbClr val="EFDAC9">
+                  <a:alpha val="69804"/>
+                </a:srgbClr>
               </a:solidFill>
               <a:ln w="4319" cap="flat">
                 <a:noFill/>
@@ -3469,10 +3910,10 @@
           </p:sp>
           <p:sp>
             <p:nvSpPr>
-              <p:cNvPr id="15" name="Freeform: Shape 14">
+              <p:cNvPr id="19" name="Freeform: Shape 18">
                 <a:extLst>
                   <a:ext uri="{FF2B5EF4-FFF2-40B4-BE49-F238E27FC236}">
-                    <a16:creationId xmlns:a16="http://schemas.microsoft.com/office/drawing/2014/main" id="{DB7CE02E-3B3F-512B-93B0-5EEB081ED4E2}"/>
+                    <a16:creationId xmlns:a16="http://schemas.microsoft.com/office/drawing/2014/main" id="{9142EB24-BE30-38ED-8E65-5AF33AA33713}"/>
                   </a:ext>
                 </a:extLst>
               </p:cNvPr>
@@ -3481,20 +3922,24 @@
             </p:nvSpPr>
             <p:spPr>
               <a:xfrm>
-                <a:off x="2998296" y="2656245"/>
-                <a:ext cx="1713456" cy="632247"/>
+                <a:off x="3034674" y="3703333"/>
+                <a:ext cx="70325" cy="124917"/>
               </a:xfrm>
               <a:custGeom>
                 <a:avLst/>
                 <a:gdLst>
-                  <a:gd name="csX0" fmla="*/ 0 w 1713456"/>
-                  <a:gd name="csY0" fmla="*/ 289027 h 632247"/>
-                  <a:gd name="csX1" fmla="*/ 927670 w 1713456"/>
-                  <a:gd name="csY1" fmla="*/ 0 h 632247"/>
-                  <a:gd name="csX2" fmla="*/ 1713456 w 1713456"/>
-                  <a:gd name="csY2" fmla="*/ 320642 h 632247"/>
-                  <a:gd name="csX3" fmla="*/ 807616 w 1713456"/>
-                  <a:gd name="csY3" fmla="*/ 632248 h 632247"/>
+                  <a:gd name="csX0" fmla="*/ 52772 w 70325"/>
+                  <a:gd name="csY0" fmla="*/ 4195 h 124917"/>
+                  <a:gd name="csX1" fmla="*/ 3320 w 70325"/>
+                  <a:gd name="csY1" fmla="*/ 35454 h 124917"/>
+                  <a:gd name="csX2" fmla="*/ 13274 w 70325"/>
+                  <a:gd name="csY2" fmla="*/ 111935 h 124917"/>
+                  <a:gd name="csX3" fmla="*/ 34233 w 70325"/>
+                  <a:gd name="csY3" fmla="*/ 124889 h 124917"/>
+                  <a:gd name="csX4" fmla="*/ 70294 w 70325"/>
+                  <a:gd name="csY4" fmla="*/ 48733 h 124917"/>
+                  <a:gd name="csX5" fmla="*/ 52772 w 70325"/>
+                  <a:gd name="csY5" fmla="*/ 4195 h 124917"/>
                 </a:gdLst>
                 <a:ahLst/>
                 <a:cxnLst>
@@ -3510,28 +3955,1077 @@
                   <a:cxn ang="0">
                     <a:pos x="csX3" y="csY3"/>
                   </a:cxn>
+                  <a:cxn ang="0">
+                    <a:pos x="csX4" y="csY4"/>
+                  </a:cxn>
+                  <a:cxn ang="0">
+                    <a:pos x="csX5" y="csY5"/>
+                  </a:cxn>
                 </a:cxnLst>
                 <a:rect l="l" t="t" r="r" b="b"/>
                 <a:pathLst>
-                  <a:path w="1713456" h="632247">
+                  <a:path w="70325" h="124917">
                     <a:moveTo>
-                      <a:pt x="0" y="289027"/>
+                      <a:pt x="52772" y="4195"/>
                     </a:moveTo>
+                    <a:cubicBezTo>
+                      <a:pt x="30705" y="-10301"/>
+                      <a:pt x="8957" y="15880"/>
+                      <a:pt x="3320" y="35454"/>
+                    </a:cubicBezTo>
+                    <a:cubicBezTo>
+                      <a:pt x="-3287" y="58396"/>
+                      <a:pt x="-66" y="91915"/>
+                      <a:pt x="13274" y="111935"/>
+                    </a:cubicBezTo>
+                    <a:cubicBezTo>
+                      <a:pt x="18041" y="119092"/>
+                      <a:pt x="25635" y="125392"/>
+                      <a:pt x="34233" y="124889"/>
+                    </a:cubicBezTo>
+                    <a:cubicBezTo>
+                      <a:pt x="64652" y="123093"/>
+                      <a:pt x="69714" y="71476"/>
+                      <a:pt x="70294" y="48733"/>
+                    </a:cubicBezTo>
+                    <a:cubicBezTo>
+                      <a:pt x="70701" y="32661"/>
+                      <a:pt x="67250" y="13711"/>
+                      <a:pt x="52772" y="4195"/>
+                    </a:cubicBezTo>
+                    <a:close/>
+                  </a:path>
+                </a:pathLst>
+              </a:custGeom>
+              <a:solidFill>
+                <a:srgbClr val="EFDAC9">
+                  <a:alpha val="69804"/>
+                </a:srgbClr>
+              </a:solidFill>
+              <a:ln w="4319" cap="flat">
+                <a:noFill/>
+                <a:prstDash val="solid"/>
+                <a:miter/>
+              </a:ln>
+            </p:spPr>
+            <p:txBody>
+              <a:bodyPr/>
+              <a:lstStyle/>
+              <a:p>
+                <a:endParaRPr lang="en-US" sz="2000"/>
+              </a:p>
+            </p:txBody>
+          </p:sp>
+        </p:grpSp>
+        <p:pic>
+          <p:nvPicPr>
+            <p:cNvPr id="1026" name="Picture 2">
+              <a:extLst>
+                <a:ext uri="{FF2B5EF4-FFF2-40B4-BE49-F238E27FC236}">
+                  <a16:creationId xmlns:a16="http://schemas.microsoft.com/office/drawing/2014/main" id="{152AB09A-3981-4A02-9E01-E7A7D792CD70}"/>
+                </a:ext>
+              </a:extLst>
+            </p:cNvPr>
+            <p:cNvPicPr>
+              <a:picLocks noChangeAspect="1" noChangeArrowheads="1"/>
+            </p:cNvPicPr>
+            <p:nvPr/>
+          </p:nvPicPr>
+          <p:blipFill>
+            <a:blip r:embed="rId2">
+              <a:extLst>
+                <a:ext uri="{28A0092B-C50C-407E-A947-70E740481C1C}">
+                  <a14:useLocalDpi xmlns:a14="http://schemas.microsoft.com/office/drawing/2010/main" val="0"/>
+                </a:ext>
+              </a:extLst>
+            </a:blip>
+            <a:srcRect/>
+            <a:stretch>
+              <a:fillRect/>
+            </a:stretch>
+          </p:blipFill>
+          <p:spPr bwMode="auto">
+            <a:xfrm>
+              <a:off x="3399757" y="689597"/>
+              <a:ext cx="809433" cy="809433"/>
+            </a:xfrm>
+            <a:prstGeom prst="rect">
+              <a:avLst/>
+            </a:prstGeom>
+            <a:noFill/>
+            <a:scene3d>
+              <a:camera prst="orthographicFront">
+                <a:rot lat="0" lon="1799990" rev="21299999"/>
+              </a:camera>
+              <a:lightRig rig="threePt" dir="t"/>
+            </a:scene3d>
+            <a:extLst>
+              <a:ext uri="{909E8E84-426E-40DD-AFC4-6F175D3DCCD1}">
+                <a14:hiddenFill xmlns:a14="http://schemas.microsoft.com/office/drawing/2010/main">
+                  <a:solidFill>
+                    <a:srgbClr val="FFFFFF"/>
+                  </a:solidFill>
+                </a14:hiddenFill>
+              </a:ext>
+            </a:extLst>
+          </p:spPr>
+        </p:pic>
+      </p:grpSp>
+      <p:sp>
+        <p:nvSpPr>
+          <p:cNvPr id="4" name="TextBox 3">
+            <a:extLst>
+              <a:ext uri="{FF2B5EF4-FFF2-40B4-BE49-F238E27FC236}">
+                <a16:creationId xmlns:a16="http://schemas.microsoft.com/office/drawing/2014/main" id="{127A7BEE-6914-407A-F0EC-4EE006C5AB5C}"/>
+              </a:ext>
+            </a:extLst>
+          </p:cNvPr>
+          <p:cNvSpPr txBox="1"/>
+          <p:nvPr/>
+        </p:nvSpPr>
+        <p:spPr>
+          <a:xfrm>
+            <a:off x="10763539" y="1512168"/>
+            <a:ext cx="1351332" cy="246221"/>
+          </a:xfrm>
+          <a:prstGeom prst="rect">
+            <a:avLst/>
+          </a:prstGeom>
+          <a:noFill/>
+        </p:spPr>
+        <p:txBody>
+          <a:bodyPr wrap="none" lIns="0" tIns="0" rIns="0" bIns="0" rtlCol="0">
+            <a:spAutoFit/>
+          </a:bodyPr>
+          <a:lstStyle/>
+          <a:p>
+            <a:pPr algn="r"/>
+            <a:r>
+              <a:rPr lang="en-US" sz="1600">
+                <a:solidFill>
+                  <a:schemeClr val="bg1">
+                    <a:lumMod val="50000"/>
+                  </a:schemeClr>
+                </a:solidFill>
+                <a:latin typeface="#9Slide03 SFU Toledo Bold" panose="00000700000000000000" pitchFamily="2" charset="0"/>
+              </a:rPr>
+              <a:t>by the-khiem7</a:t>
+            </a:r>
+          </a:p>
+        </p:txBody>
+      </p:sp>
+    </p:spTree>
+    <p:extLst>
+      <p:ext uri="{BB962C8B-B14F-4D97-AF65-F5344CB8AC3E}">
+        <p14:creationId xmlns:p14="http://schemas.microsoft.com/office/powerpoint/2010/main" val="2817079516"/>
+      </p:ext>
+    </p:extLst>
+  </p:cSld>
+  <p:clrMapOvr>
+    <a:masterClrMapping/>
+  </p:clrMapOvr>
+  <p:transition>
+    <p:fade/>
+  </p:transition>
+</p:sld>
+</file>
+
+<file path=ppt/slides/slide2.xml><?xml version="1.0" encoding="utf-8"?>
+<p:sld xmlns:a="http://schemas.openxmlformats.org/drawingml/2006/main" xmlns:r="http://schemas.openxmlformats.org/officeDocument/2006/relationships" xmlns:p="http://schemas.openxmlformats.org/presentationml/2006/main">
+  <p:cSld>
+    <p:bg>
+      <p:bgPr>
+        <a:solidFill>
+          <a:schemeClr val="bg1">
+            <a:lumMod val="95000"/>
+          </a:schemeClr>
+        </a:solidFill>
+        <a:effectLst/>
+      </p:bgPr>
+    </p:bg>
+    <p:spTree>
+      <p:nvGrpSpPr>
+        <p:cNvPr id="1" name="">
+          <a:extLst>
+            <a:ext uri="{FF2B5EF4-FFF2-40B4-BE49-F238E27FC236}">
+              <a16:creationId xmlns:a16="http://schemas.microsoft.com/office/drawing/2014/main" id="{DDD2836D-69E0-080E-96E1-F42D16F40988}"/>
+            </a:ext>
+          </a:extLst>
+        </p:cNvPr>
+        <p:cNvGrpSpPr/>
+        <p:nvPr/>
+      </p:nvGrpSpPr>
+      <p:grpSpPr>
+        <a:xfrm>
+          <a:off x="0" y="0"/>
+          <a:ext cx="0" cy="0"/>
+          <a:chOff x="0" y="0"/>
+          <a:chExt cx="0" cy="0"/>
+        </a:xfrm>
+      </p:grpSpPr>
+      <p:sp>
+        <p:nvSpPr>
+          <p:cNvPr id="2" name="Rectangle 1">
+            <a:extLst>
+              <a:ext uri="{FF2B5EF4-FFF2-40B4-BE49-F238E27FC236}">
+                <a16:creationId xmlns:a16="http://schemas.microsoft.com/office/drawing/2014/main" id="{4A462B82-E4D0-0274-C056-915BD07FE34B}"/>
+              </a:ext>
+            </a:extLst>
+          </p:cNvPr>
+          <p:cNvSpPr/>
+          <p:nvPr/>
+        </p:nvSpPr>
+        <p:spPr>
+          <a:xfrm>
+            <a:off x="0" y="0"/>
+            <a:ext cx="12192000" cy="1828800"/>
+          </a:xfrm>
+          <a:prstGeom prst="rect">
+            <a:avLst/>
+          </a:prstGeom>
+          <a:solidFill>
+            <a:schemeClr val="bg1"/>
+          </a:solidFill>
+          <a:ln>
+            <a:noFill/>
+          </a:ln>
+        </p:spPr>
+        <p:style>
+          <a:lnRef idx="2">
+            <a:schemeClr val="accent1">
+              <a:shade val="50000"/>
+            </a:schemeClr>
+          </a:lnRef>
+          <a:fillRef idx="1">
+            <a:schemeClr val="accent1"/>
+          </a:fillRef>
+          <a:effectRef idx="0">
+            <a:schemeClr val="accent1"/>
+          </a:effectRef>
+          <a:fontRef idx="minor">
+            <a:schemeClr val="lt1"/>
+          </a:fontRef>
+        </p:style>
+        <p:txBody>
+          <a:bodyPr rtlCol="0" anchor="ctr"/>
+          <a:lstStyle/>
+          <a:p>
+            <a:pPr algn="ctr"/>
+            <a:endParaRPr lang="en-US" sz="480"/>
+          </a:p>
+        </p:txBody>
+      </p:sp>
+      <p:grpSp>
+        <p:nvGrpSpPr>
+          <p:cNvPr id="6" name="Group 5">
+            <a:extLst>
+              <a:ext uri="{FF2B5EF4-FFF2-40B4-BE49-F238E27FC236}">
+                <a16:creationId xmlns:a16="http://schemas.microsoft.com/office/drawing/2014/main" id="{0F262BFE-D8E5-EAA8-8FF7-C13C4F7887E5}"/>
+              </a:ext>
+            </a:extLst>
+          </p:cNvPr>
+          <p:cNvGrpSpPr/>
+          <p:nvPr/>
+        </p:nvGrpSpPr>
+        <p:grpSpPr>
+          <a:xfrm>
+            <a:off x="6278021" y="129753"/>
+            <a:ext cx="1740985" cy="1569294"/>
+            <a:chOff x="2529261" y="138564"/>
+            <a:chExt cx="1740985" cy="1569294"/>
+          </a:xfrm>
+        </p:grpSpPr>
+        <p:grpSp>
+          <p:nvGrpSpPr>
+            <p:cNvPr id="9" name="Graphic 6">
+              <a:extLst>
+                <a:ext uri="{FF2B5EF4-FFF2-40B4-BE49-F238E27FC236}">
+                  <a16:creationId xmlns:a16="http://schemas.microsoft.com/office/drawing/2014/main" id="{D0FC299F-483B-C835-6EE0-36A8CB0D3C6B}"/>
+                </a:ext>
+              </a:extLst>
+            </p:cNvPr>
+            <p:cNvGrpSpPr/>
+            <p:nvPr/>
+          </p:nvGrpSpPr>
+          <p:grpSpPr>
+            <a:xfrm>
+              <a:off x="2529261" y="138564"/>
+              <a:ext cx="1740985" cy="1569294"/>
+              <a:chOff x="2998296" y="2656245"/>
+              <a:chExt cx="1713456" cy="1544482"/>
+            </a:xfrm>
+          </p:grpSpPr>
+          <p:grpSp>
+            <p:nvGrpSpPr>
+              <p:cNvPr id="10" name="Graphic 6">
+                <a:extLst>
+                  <a:ext uri="{FF2B5EF4-FFF2-40B4-BE49-F238E27FC236}">
+                    <a16:creationId xmlns:a16="http://schemas.microsoft.com/office/drawing/2014/main" id="{80AA2618-1FDE-2AF6-E15B-12DF8530F95F}"/>
+                  </a:ext>
+                </a:extLst>
+              </p:cNvPr>
+              <p:cNvGrpSpPr/>
+              <p:nvPr/>
+            </p:nvGrpSpPr>
+            <p:grpSpPr>
+              <a:xfrm>
+                <a:off x="2998296" y="2656245"/>
+                <a:ext cx="1713456" cy="1544482"/>
+                <a:chOff x="2998296" y="2656245"/>
+                <a:chExt cx="1713456" cy="1544482"/>
+              </a:xfrm>
+            </p:grpSpPr>
+            <p:grpSp>
+              <p:nvGrpSpPr>
+                <p:cNvPr id="11" name="Graphic 6">
+                  <a:extLst>
+                    <a:ext uri="{FF2B5EF4-FFF2-40B4-BE49-F238E27FC236}">
+                      <a16:creationId xmlns:a16="http://schemas.microsoft.com/office/drawing/2014/main" id="{E1E2929F-8DD7-BC07-EA69-6EC73B9F8F7A}"/>
+                    </a:ext>
+                  </a:extLst>
+                </p:cNvPr>
+                <p:cNvGrpSpPr/>
+                <p:nvPr/>
+              </p:nvGrpSpPr>
+              <p:grpSpPr>
+                <a:xfrm>
+                  <a:off x="2998296" y="2945286"/>
+                  <a:ext cx="1713456" cy="1255441"/>
+                  <a:chOff x="2998296" y="2945286"/>
+                  <a:chExt cx="1713456" cy="1255441"/>
+                </a:xfrm>
+              </p:grpSpPr>
+              <p:sp>
+                <p:nvSpPr>
+                  <p:cNvPr id="12" name="Freeform: Shape 11">
+                    <a:extLst>
+                      <a:ext uri="{FF2B5EF4-FFF2-40B4-BE49-F238E27FC236}">
+                        <a16:creationId xmlns:a16="http://schemas.microsoft.com/office/drawing/2014/main" id="{C7155685-3B37-3757-41E3-D3BFCB719786}"/>
+                      </a:ext>
+                    </a:extLst>
+                  </p:cNvPr>
+                  <p:cNvSpPr/>
+                  <p:nvPr/>
+                </p:nvSpPr>
+                <p:spPr>
+                  <a:xfrm>
+                    <a:off x="3805618" y="2960166"/>
+                    <a:ext cx="906134" cy="1240561"/>
+                  </a:xfrm>
+                  <a:custGeom>
+                    <a:avLst/>
+                    <a:gdLst>
+                      <a:gd name="csX0" fmla="*/ 906135 w 906134"/>
+                      <a:gd name="csY0" fmla="*/ 928956 h 1240561"/>
+                      <a:gd name="csX1" fmla="*/ 906100 w 906134"/>
+                      <a:gd name="csY1" fmla="*/ 16695 h 1240561"/>
+                      <a:gd name="csX2" fmla="*/ 0 w 906134"/>
+                      <a:gd name="csY2" fmla="*/ 0 h 1240561"/>
+                      <a:gd name="csX3" fmla="*/ 0 w 906134"/>
+                      <a:gd name="csY3" fmla="*/ 1240440 h 1240561"/>
+                      <a:gd name="csX4" fmla="*/ 294 w 906134"/>
+                      <a:gd name="csY4" fmla="*/ 1240562 h 1240561"/>
+                    </a:gdLst>
+                    <a:ahLst/>
+                    <a:cxnLst>
+                      <a:cxn ang="0">
+                        <a:pos x="csX0" y="csY0"/>
+                      </a:cxn>
+                      <a:cxn ang="0">
+                        <a:pos x="csX1" y="csY1"/>
+                      </a:cxn>
+                      <a:cxn ang="0">
+                        <a:pos x="csX2" y="csY2"/>
+                      </a:cxn>
+                      <a:cxn ang="0">
+                        <a:pos x="csX3" y="csY3"/>
+                      </a:cxn>
+                      <a:cxn ang="0">
+                        <a:pos x="csX4" y="csY4"/>
+                      </a:cxn>
+                    </a:cxnLst>
+                    <a:rect l="l" t="t" r="r" b="b"/>
+                    <a:pathLst>
+                      <a:path w="906134" h="1240561">
+                        <a:moveTo>
+                          <a:pt x="906135" y="928956"/>
+                        </a:moveTo>
+                        <a:lnTo>
+                          <a:pt x="906100" y="16695"/>
+                        </a:lnTo>
+                        <a:lnTo>
+                          <a:pt x="0" y="0"/>
+                        </a:lnTo>
+                        <a:lnTo>
+                          <a:pt x="0" y="1240440"/>
+                        </a:lnTo>
+                        <a:lnTo>
+                          <a:pt x="294" y="1240562"/>
+                        </a:lnTo>
+                        <a:close/>
+                      </a:path>
+                    </a:pathLst>
+                  </a:custGeom>
+                  <a:solidFill>
+                    <a:srgbClr val="EBCDAF"/>
+                  </a:solidFill>
+                  <a:ln w="4319" cap="flat">
+                    <a:noFill/>
+                    <a:prstDash val="solid"/>
+                    <a:miter/>
+                  </a:ln>
+                </p:spPr>
+                <p:txBody>
+                  <a:bodyPr/>
+                  <a:lstStyle/>
+                  <a:p>
+                    <a:endParaRPr lang="en-US" sz="2000"/>
+                  </a:p>
+                </p:txBody>
+              </p:sp>
+              <p:sp>
+                <p:nvSpPr>
+                  <p:cNvPr id="13" name="Freeform: Shape 12">
+                    <a:extLst>
+                      <a:ext uri="{FF2B5EF4-FFF2-40B4-BE49-F238E27FC236}">
+                        <a16:creationId xmlns:a16="http://schemas.microsoft.com/office/drawing/2014/main" id="{8BBA2CE4-C345-E069-2704-EE82C5666C96}"/>
+                      </a:ext>
+                    </a:extLst>
+                  </p:cNvPr>
+                  <p:cNvSpPr/>
+                  <p:nvPr/>
+                </p:nvSpPr>
+                <p:spPr>
+                  <a:xfrm>
+                    <a:off x="2998296" y="2945286"/>
+                    <a:ext cx="807321" cy="1255320"/>
+                  </a:xfrm>
+                  <a:custGeom>
+                    <a:avLst/>
+                    <a:gdLst>
+                      <a:gd name="csX0" fmla="*/ 13 w 807321"/>
+                      <a:gd name="csY0" fmla="*/ 0 h 1255320"/>
+                      <a:gd name="csX1" fmla="*/ 0 w 807321"/>
+                      <a:gd name="csY1" fmla="*/ 912226 h 1255320"/>
+                      <a:gd name="csX2" fmla="*/ 807321 w 807321"/>
+                      <a:gd name="csY2" fmla="*/ 1255321 h 1255320"/>
+                      <a:gd name="csX3" fmla="*/ 807321 w 807321"/>
+                      <a:gd name="csY3" fmla="*/ 14881 h 1255320"/>
+                    </a:gdLst>
+                    <a:ahLst/>
+                    <a:cxnLst>
+                      <a:cxn ang="0">
+                        <a:pos x="csX0" y="csY0"/>
+                      </a:cxn>
+                      <a:cxn ang="0">
+                        <a:pos x="csX1" y="csY1"/>
+                      </a:cxn>
+                      <a:cxn ang="0">
+                        <a:pos x="csX2" y="csY2"/>
+                      </a:cxn>
+                      <a:cxn ang="0">
+                        <a:pos x="csX3" y="csY3"/>
+                      </a:cxn>
+                    </a:cxnLst>
+                    <a:rect l="l" t="t" r="r" b="b"/>
+                    <a:pathLst>
+                      <a:path w="807321" h="1255320">
+                        <a:moveTo>
+                          <a:pt x="13" y="0"/>
+                        </a:moveTo>
+                        <a:lnTo>
+                          <a:pt x="0" y="912226"/>
+                        </a:lnTo>
+                        <a:lnTo>
+                          <a:pt x="807321" y="1255321"/>
+                        </a:lnTo>
+                        <a:lnTo>
+                          <a:pt x="807321" y="14881"/>
+                        </a:lnTo>
+                        <a:close/>
+                      </a:path>
+                    </a:pathLst>
+                  </a:custGeom>
+                  <a:solidFill>
+                    <a:srgbClr val="C49772"/>
+                  </a:solidFill>
+                  <a:ln w="4319" cap="flat">
+                    <a:noFill/>
+                    <a:prstDash val="solid"/>
+                    <a:miter/>
+                  </a:ln>
+                </p:spPr>
+                <p:txBody>
+                  <a:bodyPr/>
+                  <a:lstStyle/>
+                  <a:p>
+                    <a:endParaRPr lang="en-US" sz="2000"/>
+                  </a:p>
+                </p:txBody>
+              </p:sp>
+            </p:grpSp>
+            <p:sp>
+              <p:nvSpPr>
+                <p:cNvPr id="14" name="Freeform: Shape 13">
+                  <a:extLst>
+                    <a:ext uri="{FF2B5EF4-FFF2-40B4-BE49-F238E27FC236}">
+                      <a16:creationId xmlns:a16="http://schemas.microsoft.com/office/drawing/2014/main" id="{B212CB9D-6369-6B48-8A09-B8F9E292CD85}"/>
+                    </a:ext>
+                  </a:extLst>
+                </p:cNvPr>
+                <p:cNvSpPr/>
+                <p:nvPr/>
+              </p:nvSpPr>
+              <p:spPr>
+                <a:xfrm>
+                  <a:off x="3253315" y="2978385"/>
+                  <a:ext cx="269691" cy="628069"/>
+                </a:xfrm>
+                <a:custGeom>
+                  <a:avLst/>
+                  <a:gdLst>
+                    <a:gd name="csX0" fmla="*/ 11781 w 269691"/>
+                    <a:gd name="csY0" fmla="*/ 0 h 628069"/>
+                    <a:gd name="csX1" fmla="*/ 0 w 269691"/>
+                    <a:gd name="csY1" fmla="*/ 75265 h 628069"/>
+                    <a:gd name="csX2" fmla="*/ 0 w 269691"/>
+                    <a:gd name="csY2" fmla="*/ 495391 h 628069"/>
+                    <a:gd name="csX3" fmla="*/ 34974 w 269691"/>
+                    <a:gd name="csY3" fmla="*/ 480843 h 628069"/>
+                    <a:gd name="csX4" fmla="*/ 47859 w 269691"/>
+                    <a:gd name="csY4" fmla="*/ 524174 h 628069"/>
+                    <a:gd name="csX5" fmla="*/ 89604 w 269691"/>
+                    <a:gd name="csY5" fmla="*/ 506816 h 628069"/>
+                    <a:gd name="csX6" fmla="*/ 102493 w 269691"/>
+                    <a:gd name="csY6" fmla="*/ 550146 h 628069"/>
+                    <a:gd name="csX7" fmla="*/ 144234 w 269691"/>
+                    <a:gd name="csY7" fmla="*/ 532789 h 628069"/>
+                    <a:gd name="csX8" fmla="*/ 157123 w 269691"/>
+                    <a:gd name="csY8" fmla="*/ 576124 h 628069"/>
+                    <a:gd name="csX9" fmla="*/ 198873 w 269691"/>
+                    <a:gd name="csY9" fmla="*/ 558771 h 628069"/>
+                    <a:gd name="csX10" fmla="*/ 211749 w 269691"/>
+                    <a:gd name="csY10" fmla="*/ 602097 h 628069"/>
+                    <a:gd name="csX11" fmla="*/ 253490 w 269691"/>
+                    <a:gd name="csY11" fmla="*/ 584740 h 628069"/>
+                    <a:gd name="csX12" fmla="*/ 266380 w 269691"/>
+                    <a:gd name="csY12" fmla="*/ 628070 h 628069"/>
+                    <a:gd name="csX13" fmla="*/ 268765 w 269691"/>
+                    <a:gd name="csY13" fmla="*/ 627078 h 628069"/>
+                    <a:gd name="csX14" fmla="*/ 269692 w 269691"/>
+                    <a:gd name="csY14" fmla="*/ 57314 h 628069"/>
+                  </a:gdLst>
+                  <a:ahLst/>
+                  <a:cxnLst>
+                    <a:cxn ang="0">
+                      <a:pos x="csX0" y="csY0"/>
+                    </a:cxn>
+                    <a:cxn ang="0">
+                      <a:pos x="csX1" y="csY1"/>
+                    </a:cxn>
+                    <a:cxn ang="0">
+                      <a:pos x="csX2" y="csY2"/>
+                    </a:cxn>
+                    <a:cxn ang="0">
+                      <a:pos x="csX3" y="csY3"/>
+                    </a:cxn>
+                    <a:cxn ang="0">
+                      <a:pos x="csX4" y="csY4"/>
+                    </a:cxn>
+                    <a:cxn ang="0">
+                      <a:pos x="csX5" y="csY5"/>
+                    </a:cxn>
+                    <a:cxn ang="0">
+                      <a:pos x="csX6" y="csY6"/>
+                    </a:cxn>
+                    <a:cxn ang="0">
+                      <a:pos x="csX7" y="csY7"/>
+                    </a:cxn>
+                    <a:cxn ang="0">
+                      <a:pos x="csX8" y="csY8"/>
+                    </a:cxn>
+                    <a:cxn ang="0">
+                      <a:pos x="csX9" y="csY9"/>
+                    </a:cxn>
+                    <a:cxn ang="0">
+                      <a:pos x="csX10" y="csY10"/>
+                    </a:cxn>
+                    <a:cxn ang="0">
+                      <a:pos x="csX11" y="csY11"/>
+                    </a:cxn>
+                    <a:cxn ang="0">
+                      <a:pos x="csX12" y="csY12"/>
+                    </a:cxn>
+                    <a:cxn ang="0">
+                      <a:pos x="csX13" y="csY13"/>
+                    </a:cxn>
+                    <a:cxn ang="0">
+                      <a:pos x="csX14" y="csY14"/>
+                    </a:cxn>
+                  </a:cxnLst>
+                  <a:rect l="l" t="t" r="r" b="b"/>
+                  <a:pathLst>
+                    <a:path w="269691" h="628069">
+                      <a:moveTo>
+                        <a:pt x="11781" y="0"/>
+                      </a:moveTo>
+                      <a:lnTo>
+                        <a:pt x="0" y="75265"/>
+                      </a:lnTo>
+                      <a:lnTo>
+                        <a:pt x="0" y="495391"/>
+                      </a:lnTo>
+                      <a:lnTo>
+                        <a:pt x="34974" y="480843"/>
+                      </a:lnTo>
+                      <a:lnTo>
+                        <a:pt x="47859" y="524174"/>
+                      </a:lnTo>
+                      <a:lnTo>
+                        <a:pt x="89604" y="506816"/>
+                      </a:lnTo>
+                      <a:lnTo>
+                        <a:pt x="102493" y="550146"/>
+                      </a:lnTo>
+                      <a:lnTo>
+                        <a:pt x="144234" y="532789"/>
+                      </a:lnTo>
+                      <a:lnTo>
+                        <a:pt x="157123" y="576124"/>
+                      </a:lnTo>
+                      <a:lnTo>
+                        <a:pt x="198873" y="558771"/>
+                      </a:lnTo>
+                      <a:lnTo>
+                        <a:pt x="211749" y="602097"/>
+                      </a:lnTo>
+                      <a:lnTo>
+                        <a:pt x="253490" y="584740"/>
+                      </a:lnTo>
+                      <a:lnTo>
+                        <a:pt x="266380" y="628070"/>
+                      </a:lnTo>
+                      <a:lnTo>
+                        <a:pt x="268765" y="627078"/>
+                      </a:lnTo>
+                      <a:lnTo>
+                        <a:pt x="269692" y="57314"/>
+                      </a:lnTo>
+                      <a:close/>
+                    </a:path>
+                  </a:pathLst>
+                </a:custGeom>
+                <a:solidFill>
+                  <a:srgbClr val="DBB693"/>
+                </a:solidFill>
+                <a:ln w="4319" cap="flat">
+                  <a:noFill/>
+                  <a:prstDash val="solid"/>
+                  <a:miter/>
+                </a:ln>
+              </p:spPr>
+              <p:txBody>
+                <a:bodyPr/>
+                <a:lstStyle/>
+                <a:p>
+                  <a:endParaRPr lang="en-US" sz="2000"/>
+                </a:p>
+              </p:txBody>
+            </p:sp>
+            <p:sp>
+              <p:nvSpPr>
+                <p:cNvPr id="15" name="Freeform: Shape 14">
+                  <a:extLst>
+                    <a:ext uri="{FF2B5EF4-FFF2-40B4-BE49-F238E27FC236}">
+                      <a16:creationId xmlns:a16="http://schemas.microsoft.com/office/drawing/2014/main" id="{068E5B74-2D71-E90B-CBCA-3A6364F0BCC8}"/>
+                    </a:ext>
+                  </a:extLst>
+                </p:cNvPr>
+                <p:cNvSpPr/>
+                <p:nvPr/>
+              </p:nvSpPr>
+              <p:spPr>
+                <a:xfrm>
+                  <a:off x="2998296" y="2656245"/>
+                  <a:ext cx="1713456" cy="632247"/>
+                </a:xfrm>
+                <a:custGeom>
+                  <a:avLst/>
+                  <a:gdLst>
+                    <a:gd name="csX0" fmla="*/ 0 w 1713456"/>
+                    <a:gd name="csY0" fmla="*/ 289027 h 632247"/>
+                    <a:gd name="csX1" fmla="*/ 927670 w 1713456"/>
+                    <a:gd name="csY1" fmla="*/ 0 h 632247"/>
+                    <a:gd name="csX2" fmla="*/ 1713456 w 1713456"/>
+                    <a:gd name="csY2" fmla="*/ 320642 h 632247"/>
+                    <a:gd name="csX3" fmla="*/ 807616 w 1713456"/>
+                    <a:gd name="csY3" fmla="*/ 632248 h 632247"/>
+                  </a:gdLst>
+                  <a:ahLst/>
+                  <a:cxnLst>
+                    <a:cxn ang="0">
+                      <a:pos x="csX0" y="csY0"/>
+                    </a:cxn>
+                    <a:cxn ang="0">
+                      <a:pos x="csX1" y="csY1"/>
+                    </a:cxn>
+                    <a:cxn ang="0">
+                      <a:pos x="csX2" y="csY2"/>
+                    </a:cxn>
+                    <a:cxn ang="0">
+                      <a:pos x="csX3" y="csY3"/>
+                    </a:cxn>
+                  </a:cxnLst>
+                  <a:rect l="l" t="t" r="r" b="b"/>
+                  <a:pathLst>
+                    <a:path w="1713456" h="632247">
+                      <a:moveTo>
+                        <a:pt x="0" y="289027"/>
+                      </a:moveTo>
+                      <a:lnTo>
+                        <a:pt x="927670" y="0"/>
+                      </a:lnTo>
+                      <a:lnTo>
+                        <a:pt x="1713456" y="320642"/>
+                      </a:lnTo>
+                      <a:lnTo>
+                        <a:pt x="807616" y="632248"/>
+                      </a:lnTo>
+                      <a:close/>
+                    </a:path>
+                  </a:pathLst>
+                </a:custGeom>
+                <a:solidFill>
+                  <a:srgbClr val="D09565"/>
+                </a:solidFill>
+                <a:ln w="4319" cap="flat">
+                  <a:noFill/>
+                  <a:prstDash val="solid"/>
+                  <a:miter/>
+                </a:ln>
+              </p:spPr>
+              <p:txBody>
+                <a:bodyPr/>
+                <a:lstStyle/>
+                <a:p>
+                  <a:endParaRPr lang="en-US" sz="2000"/>
+                </a:p>
+              </p:txBody>
+            </p:sp>
+            <p:sp>
+              <p:nvSpPr>
+                <p:cNvPr id="16" name="Freeform: Shape 15">
+                  <a:extLst>
+                    <a:ext uri="{FF2B5EF4-FFF2-40B4-BE49-F238E27FC236}">
+                      <a16:creationId xmlns:a16="http://schemas.microsoft.com/office/drawing/2014/main" id="{8864ACD4-24FD-E800-0B40-1CCB4FCCF3B3}"/>
+                    </a:ext>
+                  </a:extLst>
+                </p:cNvPr>
+                <p:cNvSpPr/>
+                <p:nvPr/>
+              </p:nvSpPr>
+              <p:spPr>
+                <a:xfrm>
+                  <a:off x="3253315" y="2748759"/>
+                  <a:ext cx="1151693" cy="421225"/>
+                </a:xfrm>
+                <a:custGeom>
+                  <a:avLst/>
+                  <a:gdLst>
+                    <a:gd name="csX0" fmla="*/ 899368 w 1151693"/>
+                    <a:gd name="csY0" fmla="*/ 0 h 421225"/>
+                    <a:gd name="csX1" fmla="*/ 0 w 1151693"/>
+                    <a:gd name="csY1" fmla="*/ 304891 h 421225"/>
+                    <a:gd name="csX2" fmla="*/ 273744 w 1151693"/>
+                    <a:gd name="csY2" fmla="*/ 421226 h 421225"/>
+                    <a:gd name="csX3" fmla="*/ 1151693 w 1151693"/>
+                    <a:gd name="csY3" fmla="*/ 102961 h 421225"/>
+                  </a:gdLst>
+                  <a:ahLst/>
+                  <a:cxnLst>
+                    <a:cxn ang="0">
+                      <a:pos x="csX0" y="csY0"/>
+                    </a:cxn>
+                    <a:cxn ang="0">
+                      <a:pos x="csX1" y="csY1"/>
+                    </a:cxn>
+                    <a:cxn ang="0">
+                      <a:pos x="csX2" y="csY2"/>
+                    </a:cxn>
+                    <a:cxn ang="0">
+                      <a:pos x="csX3" y="csY3"/>
+                    </a:cxn>
+                  </a:cxnLst>
+                  <a:rect l="l" t="t" r="r" b="b"/>
+                  <a:pathLst>
+                    <a:path w="1151693" h="421225">
+                      <a:moveTo>
+                        <a:pt x="899368" y="0"/>
+                      </a:moveTo>
+                      <a:lnTo>
+                        <a:pt x="0" y="304891"/>
+                      </a:lnTo>
+                      <a:lnTo>
+                        <a:pt x="273744" y="421226"/>
+                      </a:lnTo>
+                      <a:lnTo>
+                        <a:pt x="1151693" y="102961"/>
+                      </a:lnTo>
+                      <a:close/>
+                    </a:path>
+                  </a:pathLst>
+                </a:custGeom>
+                <a:solidFill>
+                  <a:srgbClr val="F3DEB4"/>
+                </a:solidFill>
+                <a:ln w="4319" cap="flat">
+                  <a:noFill/>
+                  <a:prstDash val="solid"/>
+                  <a:miter/>
+                </a:ln>
+              </p:spPr>
+              <p:txBody>
+                <a:bodyPr/>
+                <a:lstStyle/>
+                <a:p>
+                  <a:endParaRPr lang="en-US" sz="2000"/>
+                </a:p>
+              </p:txBody>
+            </p:sp>
+            <p:sp>
+              <p:nvSpPr>
+                <p:cNvPr id="17" name="Freeform: Shape 16">
+                  <a:extLst>
+                    <a:ext uri="{FF2B5EF4-FFF2-40B4-BE49-F238E27FC236}">
+                      <a16:creationId xmlns:a16="http://schemas.microsoft.com/office/drawing/2014/main" id="{C45294C7-791F-FD88-4A32-9273818FC424}"/>
+                    </a:ext>
+                  </a:extLst>
+                </p:cNvPr>
+                <p:cNvSpPr/>
+                <p:nvPr/>
+              </p:nvSpPr>
+              <p:spPr>
+                <a:xfrm>
+                  <a:off x="2998296" y="2656245"/>
+                  <a:ext cx="1713456" cy="320641"/>
+                </a:xfrm>
+                <a:custGeom>
+                  <a:avLst/>
+                  <a:gdLst>
+                    <a:gd name="csX0" fmla="*/ 0 w 1713456"/>
+                    <a:gd name="csY0" fmla="*/ 289027 h 320641"/>
+                    <a:gd name="csX1" fmla="*/ 927670 w 1713456"/>
+                    <a:gd name="csY1" fmla="*/ 0 h 320641"/>
+                    <a:gd name="csX2" fmla="*/ 1713456 w 1713456"/>
+                    <a:gd name="csY2" fmla="*/ 320642 h 320641"/>
+                    <a:gd name="csX3" fmla="*/ 933805 w 1713456"/>
+                    <a:gd name="csY3" fmla="*/ 32610 h 320641"/>
+                  </a:gdLst>
+                  <a:ahLst/>
+                  <a:cxnLst>
+                    <a:cxn ang="0">
+                      <a:pos x="csX0" y="csY0"/>
+                    </a:cxn>
+                    <a:cxn ang="0">
+                      <a:pos x="csX1" y="csY1"/>
+                    </a:cxn>
+                    <a:cxn ang="0">
+                      <a:pos x="csX2" y="csY2"/>
+                    </a:cxn>
+                    <a:cxn ang="0">
+                      <a:pos x="csX3" y="csY3"/>
+                    </a:cxn>
+                  </a:cxnLst>
+                  <a:rect l="l" t="t" r="r" b="b"/>
+                  <a:pathLst>
+                    <a:path w="1713456" h="320641">
+                      <a:moveTo>
+                        <a:pt x="0" y="289027"/>
+                      </a:moveTo>
+                      <a:lnTo>
+                        <a:pt x="927670" y="0"/>
+                      </a:lnTo>
+                      <a:lnTo>
+                        <a:pt x="1713456" y="320642"/>
+                      </a:lnTo>
+                      <a:lnTo>
+                        <a:pt x="933805" y="32610"/>
+                      </a:lnTo>
+                      <a:close/>
+                    </a:path>
+                  </a:pathLst>
+                </a:custGeom>
+                <a:solidFill>
+                  <a:srgbClr val="E5BE97">
+                    <a:alpha val="52000"/>
+                  </a:srgbClr>
+                </a:solidFill>
+                <a:ln w="4319" cap="flat">
+                  <a:noFill/>
+                  <a:prstDash val="solid"/>
+                  <a:miter/>
+                </a:ln>
+              </p:spPr>
+              <p:txBody>
+                <a:bodyPr/>
+                <a:lstStyle/>
+                <a:p>
+                  <a:endParaRPr lang="en-US" sz="2000"/>
+                </a:p>
+              </p:txBody>
+            </p:sp>
+          </p:grpSp>
+          <p:sp>
+            <p:nvSpPr>
+              <p:cNvPr id="18" name="Freeform: Shape 17">
+                <a:extLst>
+                  <a:ext uri="{FF2B5EF4-FFF2-40B4-BE49-F238E27FC236}">
+                    <a16:creationId xmlns:a16="http://schemas.microsoft.com/office/drawing/2014/main" id="{C77A636D-6BA5-3007-0334-8B8883FA5CE7}"/>
+                  </a:ext>
+                </a:extLst>
+              </p:cNvPr>
+              <p:cNvSpPr/>
+              <p:nvPr/>
+            </p:nvSpPr>
+            <p:spPr>
+              <a:xfrm>
+                <a:off x="3033801" y="3025729"/>
+                <a:ext cx="147679" cy="648615"/>
+              </a:xfrm>
+              <a:custGeom>
+                <a:avLst/>
+                <a:gdLst>
+                  <a:gd name="csX0" fmla="*/ 146791 w 147679"/>
+                  <a:gd name="csY0" fmla="*/ 224308 h 648615"/>
+                  <a:gd name="csX1" fmla="*/ 128689 w 147679"/>
+                  <a:gd name="csY1" fmla="*/ 119256 h 648615"/>
+                  <a:gd name="csX2" fmla="*/ 74310 w 147679"/>
+                  <a:gd name="csY2" fmla="*/ 21720 h 648615"/>
+                  <a:gd name="csX3" fmla="*/ 11254 w 147679"/>
+                  <a:gd name="csY3" fmla="*/ 27020 h 648615"/>
+                  <a:gd name="csX4" fmla="*/ 1197 w 147679"/>
+                  <a:gd name="csY4" fmla="*/ 203670 h 648615"/>
+                  <a:gd name="csX5" fmla="*/ 1764 w 147679"/>
+                  <a:gd name="csY5" fmla="*/ 576859 h 648615"/>
+                  <a:gd name="csX6" fmla="*/ 6665 w 147679"/>
+                  <a:gd name="csY6" fmla="*/ 616574 h 648615"/>
+                  <a:gd name="csX7" fmla="*/ 54173 w 147679"/>
+                  <a:gd name="csY7" fmla="*/ 640460 h 648615"/>
+                  <a:gd name="csX8" fmla="*/ 81839 w 147679"/>
+                  <a:gd name="csY8" fmla="*/ 600905 h 648615"/>
+                  <a:gd name="csX9" fmla="*/ 115523 w 147679"/>
+                  <a:gd name="csY9" fmla="*/ 514847 h 648615"/>
+                  <a:gd name="csX10" fmla="*/ 146843 w 147679"/>
+                  <a:gd name="csY10" fmla="*/ 225174 h 648615"/>
+                  <a:gd name="csX11" fmla="*/ 146791 w 147679"/>
+                  <a:gd name="csY11" fmla="*/ 224308 h 648615"/>
+                </a:gdLst>
+                <a:ahLst/>
+                <a:cxnLst>
+                  <a:cxn ang="0">
+                    <a:pos x="csX0" y="csY0"/>
+                  </a:cxn>
+                  <a:cxn ang="0">
+                    <a:pos x="csX1" y="csY1"/>
+                  </a:cxn>
+                  <a:cxn ang="0">
+                    <a:pos x="csX2" y="csY2"/>
+                  </a:cxn>
+                  <a:cxn ang="0">
+                    <a:pos x="csX3" y="csY3"/>
+                  </a:cxn>
+                  <a:cxn ang="0">
+                    <a:pos x="csX4" y="csY4"/>
+                  </a:cxn>
+                  <a:cxn ang="0">
+                    <a:pos x="csX5" y="csY5"/>
+                  </a:cxn>
+                  <a:cxn ang="0">
+                    <a:pos x="csX6" y="csY6"/>
+                  </a:cxn>
+                  <a:cxn ang="0">
+                    <a:pos x="csX7" y="csY7"/>
+                  </a:cxn>
+                  <a:cxn ang="0">
+                    <a:pos x="csX8" y="csY8"/>
+                  </a:cxn>
+                  <a:cxn ang="0">
+                    <a:pos x="csX9" y="csY9"/>
+                  </a:cxn>
+                  <a:cxn ang="0">
+                    <a:pos x="csX10" y="csY10"/>
+                  </a:cxn>
+                  <a:cxn ang="0">
+                    <a:pos x="csX11" y="csY11"/>
+                  </a:cxn>
+                </a:cxnLst>
+                <a:rect l="l" t="t" r="r" b="b"/>
+                <a:pathLst>
+                  <a:path w="147679" h="648615">
+                    <a:moveTo>
+                      <a:pt x="146791" y="224308"/>
+                    </a:moveTo>
+                    <a:cubicBezTo>
+                      <a:pt x="144760" y="188984"/>
+                      <a:pt x="139552" y="153282"/>
+                      <a:pt x="128689" y="119256"/>
+                    </a:cubicBezTo>
+                    <a:cubicBezTo>
+                      <a:pt x="117194" y="83235"/>
+                      <a:pt x="99209" y="48793"/>
+                      <a:pt x="74310" y="21720"/>
+                    </a:cubicBezTo>
+                    <a:cubicBezTo>
+                      <a:pt x="53654" y="-1473"/>
+                      <a:pt x="21104" y="-14544"/>
+                      <a:pt x="11254" y="27020"/>
+                    </a:cubicBezTo>
+                    <a:cubicBezTo>
+                      <a:pt x="1478" y="84733"/>
+                      <a:pt x="3007" y="145073"/>
+                      <a:pt x="1197" y="203670"/>
+                    </a:cubicBezTo>
+                    <a:cubicBezTo>
+                      <a:pt x="123" y="328187"/>
+                      <a:pt x="-1085" y="452705"/>
+                      <a:pt x="1764" y="576859"/>
+                    </a:cubicBezTo>
+                    <a:cubicBezTo>
+                      <a:pt x="2461" y="590376"/>
+                      <a:pt x="3526" y="604222"/>
+                      <a:pt x="6665" y="616574"/>
+                    </a:cubicBezTo>
+                    <a:cubicBezTo>
+                      <a:pt x="12302" y="642967"/>
+                      <a:pt x="32807" y="659341"/>
+                      <a:pt x="54173" y="640460"/>
+                    </a:cubicBezTo>
+                    <a:cubicBezTo>
+                      <a:pt x="66331" y="630173"/>
+                      <a:pt x="74708" y="615167"/>
+                      <a:pt x="81839" y="600905"/>
+                    </a:cubicBezTo>
+                    <a:cubicBezTo>
+                      <a:pt x="95248" y="573378"/>
+                      <a:pt x="106426" y="544431"/>
+                      <a:pt x="115523" y="514847"/>
+                    </a:cubicBezTo>
+                    <a:cubicBezTo>
+                      <a:pt x="143383" y="421580"/>
+                      <a:pt x="150350" y="321974"/>
+                      <a:pt x="146843" y="225174"/>
+                    </a:cubicBezTo>
                     <a:lnTo>
-                      <a:pt x="927670" y="0"/>
-                    </a:lnTo>
-                    <a:lnTo>
-                      <a:pt x="1713456" y="320642"/>
-                    </a:lnTo>
-                    <a:lnTo>
-                      <a:pt x="807616" y="632248"/>
+                      <a:pt x="146791" y="224308"/>
                     </a:lnTo>
                     <a:close/>
                   </a:path>
                 </a:pathLst>
               </a:custGeom>
               <a:solidFill>
-                <a:srgbClr val="D09565"/>
+                <a:srgbClr val="EFDAC9">
+                  <a:alpha val="69804"/>
+                </a:srgbClr>
               </a:solidFill>
               <a:ln w="4319" cap="flat">
                 <a:noFill/>
@@ -3549,10 +5043,10 @@
           </p:sp>
           <p:sp>
             <p:nvSpPr>
-              <p:cNvPr id="16" name="Freeform: Shape 15">
+              <p:cNvPr id="19" name="Freeform: Shape 18">
                 <a:extLst>
                   <a:ext uri="{FF2B5EF4-FFF2-40B4-BE49-F238E27FC236}">
-                    <a16:creationId xmlns:a16="http://schemas.microsoft.com/office/drawing/2014/main" id="{A2E30E63-4C38-1D62-3576-07CEB4335180}"/>
+                    <a16:creationId xmlns:a16="http://schemas.microsoft.com/office/drawing/2014/main" id="{340DB5A6-9DC2-E7B2-CE85-A6FA57CF5BA1}"/>
                   </a:ext>
                 </a:extLst>
               </p:cNvPr>
@@ -3561,20 +5055,24 @@
             </p:nvSpPr>
             <p:spPr>
               <a:xfrm>
-                <a:off x="3253315" y="2748759"/>
-                <a:ext cx="1151693" cy="421225"/>
+                <a:off x="3034674" y="3703333"/>
+                <a:ext cx="70325" cy="124917"/>
               </a:xfrm>
               <a:custGeom>
                 <a:avLst/>
                 <a:gdLst>
-                  <a:gd name="csX0" fmla="*/ 899368 w 1151693"/>
-                  <a:gd name="csY0" fmla="*/ 0 h 421225"/>
-                  <a:gd name="csX1" fmla="*/ 0 w 1151693"/>
-                  <a:gd name="csY1" fmla="*/ 304891 h 421225"/>
-                  <a:gd name="csX2" fmla="*/ 273744 w 1151693"/>
-                  <a:gd name="csY2" fmla="*/ 421226 h 421225"/>
-                  <a:gd name="csX3" fmla="*/ 1151693 w 1151693"/>
-                  <a:gd name="csY3" fmla="*/ 102961 h 421225"/>
+                  <a:gd name="csX0" fmla="*/ 52772 w 70325"/>
+                  <a:gd name="csY0" fmla="*/ 4195 h 124917"/>
+                  <a:gd name="csX1" fmla="*/ 3320 w 70325"/>
+                  <a:gd name="csY1" fmla="*/ 35454 h 124917"/>
+                  <a:gd name="csX2" fmla="*/ 13274 w 70325"/>
+                  <a:gd name="csY2" fmla="*/ 111935 h 124917"/>
+                  <a:gd name="csX3" fmla="*/ 34233 w 70325"/>
+                  <a:gd name="csY3" fmla="*/ 124889 h 124917"/>
+                  <a:gd name="csX4" fmla="*/ 70294 w 70325"/>
+                  <a:gd name="csY4" fmla="*/ 48733 h 124917"/>
+                  <a:gd name="csX5" fmla="*/ 52772 w 70325"/>
+                  <a:gd name="csY5" fmla="*/ 4195 h 124917"/>
                 </a:gdLst>
                 <a:ahLst/>
                 <a:cxnLst>
@@ -3590,109 +5088,51 @@
                   <a:cxn ang="0">
                     <a:pos x="csX3" y="csY3"/>
                   </a:cxn>
+                  <a:cxn ang="0">
+                    <a:pos x="csX4" y="csY4"/>
+                  </a:cxn>
+                  <a:cxn ang="0">
+                    <a:pos x="csX5" y="csY5"/>
+                  </a:cxn>
                 </a:cxnLst>
                 <a:rect l="l" t="t" r="r" b="b"/>
                 <a:pathLst>
-                  <a:path w="1151693" h="421225">
+                  <a:path w="70325" h="124917">
                     <a:moveTo>
-                      <a:pt x="899368" y="0"/>
+                      <a:pt x="52772" y="4195"/>
                     </a:moveTo>
-                    <a:lnTo>
-                      <a:pt x="0" y="304891"/>
-                    </a:lnTo>
-                    <a:lnTo>
-                      <a:pt x="273744" y="421226"/>
-                    </a:lnTo>
-                    <a:lnTo>
-                      <a:pt x="1151693" y="102961"/>
-                    </a:lnTo>
+                    <a:cubicBezTo>
+                      <a:pt x="30705" y="-10301"/>
+                      <a:pt x="8957" y="15880"/>
+                      <a:pt x="3320" y="35454"/>
+                    </a:cubicBezTo>
+                    <a:cubicBezTo>
+                      <a:pt x="-3287" y="58396"/>
+                      <a:pt x="-66" y="91915"/>
+                      <a:pt x="13274" y="111935"/>
+                    </a:cubicBezTo>
+                    <a:cubicBezTo>
+                      <a:pt x="18041" y="119092"/>
+                      <a:pt x="25635" y="125392"/>
+                      <a:pt x="34233" y="124889"/>
+                    </a:cubicBezTo>
+                    <a:cubicBezTo>
+                      <a:pt x="64652" y="123093"/>
+                      <a:pt x="69714" y="71476"/>
+                      <a:pt x="70294" y="48733"/>
+                    </a:cubicBezTo>
+                    <a:cubicBezTo>
+                      <a:pt x="70701" y="32661"/>
+                      <a:pt x="67250" y="13711"/>
+                      <a:pt x="52772" y="4195"/>
+                    </a:cubicBezTo>
                     <a:close/>
                   </a:path>
                 </a:pathLst>
               </a:custGeom>
               <a:solidFill>
-                <a:srgbClr val="F3DEB4"/>
-              </a:solidFill>
-              <a:ln w="4319" cap="flat">
-                <a:noFill/>
-                <a:prstDash val="solid"/>
-                <a:miter/>
-              </a:ln>
-            </p:spPr>
-            <p:txBody>
-              <a:bodyPr/>
-              <a:lstStyle/>
-              <a:p>
-                <a:endParaRPr lang="en-US" sz="2000"/>
-              </a:p>
-            </p:txBody>
-          </p:sp>
-          <p:sp>
-            <p:nvSpPr>
-              <p:cNvPr id="17" name="Freeform: Shape 16">
-                <a:extLst>
-                  <a:ext uri="{FF2B5EF4-FFF2-40B4-BE49-F238E27FC236}">
-                    <a16:creationId xmlns:a16="http://schemas.microsoft.com/office/drawing/2014/main" id="{8E9B7BBC-80F3-9D68-57E8-7F7CEC8D8FAC}"/>
-                  </a:ext>
-                </a:extLst>
-              </p:cNvPr>
-              <p:cNvSpPr/>
-              <p:nvPr/>
-            </p:nvSpPr>
-            <p:spPr>
-              <a:xfrm>
-                <a:off x="2998296" y="2656245"/>
-                <a:ext cx="1713456" cy="320641"/>
-              </a:xfrm>
-              <a:custGeom>
-                <a:avLst/>
-                <a:gdLst>
-                  <a:gd name="csX0" fmla="*/ 0 w 1713456"/>
-                  <a:gd name="csY0" fmla="*/ 289027 h 320641"/>
-                  <a:gd name="csX1" fmla="*/ 927670 w 1713456"/>
-                  <a:gd name="csY1" fmla="*/ 0 h 320641"/>
-                  <a:gd name="csX2" fmla="*/ 1713456 w 1713456"/>
-                  <a:gd name="csY2" fmla="*/ 320642 h 320641"/>
-                  <a:gd name="csX3" fmla="*/ 933805 w 1713456"/>
-                  <a:gd name="csY3" fmla="*/ 32610 h 320641"/>
-                </a:gdLst>
-                <a:ahLst/>
-                <a:cxnLst>
-                  <a:cxn ang="0">
-                    <a:pos x="csX0" y="csY0"/>
-                  </a:cxn>
-                  <a:cxn ang="0">
-                    <a:pos x="csX1" y="csY1"/>
-                  </a:cxn>
-                  <a:cxn ang="0">
-                    <a:pos x="csX2" y="csY2"/>
-                  </a:cxn>
-                  <a:cxn ang="0">
-                    <a:pos x="csX3" y="csY3"/>
-                  </a:cxn>
-                </a:cxnLst>
-                <a:rect l="l" t="t" r="r" b="b"/>
-                <a:pathLst>
-                  <a:path w="1713456" h="320641">
-                    <a:moveTo>
-                      <a:pt x="0" y="289027"/>
-                    </a:moveTo>
-                    <a:lnTo>
-                      <a:pt x="927670" y="0"/>
-                    </a:lnTo>
-                    <a:lnTo>
-                      <a:pt x="1713456" y="320642"/>
-                    </a:lnTo>
-                    <a:lnTo>
-                      <a:pt x="933805" y="32610"/>
-                    </a:lnTo>
-                    <a:close/>
-                  </a:path>
-                </a:pathLst>
-              </a:custGeom>
-              <a:solidFill>
-                <a:srgbClr val="E5BE97">
-                  <a:alpha val="52000"/>
+                <a:srgbClr val="EFDAC9">
+                  <a:alpha val="69804"/>
                 </a:srgbClr>
               </a:solidFill>
               <a:ln w="4319" cap="flat">
@@ -3710,338 +5150,188 @@
             </p:txBody>
           </p:sp>
         </p:grpSp>
-        <p:sp>
-          <p:nvSpPr>
-            <p:cNvPr id="18" name="Freeform: Shape 17">
+        <p:pic>
+          <p:nvPicPr>
+            <p:cNvPr id="1026" name="Picture 2">
               <a:extLst>
                 <a:ext uri="{FF2B5EF4-FFF2-40B4-BE49-F238E27FC236}">
-                  <a16:creationId xmlns:a16="http://schemas.microsoft.com/office/drawing/2014/main" id="{ADD56887-5F39-E9D3-57AE-08202AF25066}"/>
+                  <a16:creationId xmlns:a16="http://schemas.microsoft.com/office/drawing/2014/main" id="{3CEA8A6D-C1CE-E672-FA2E-C3E7A0C150BE}"/>
                 </a:ext>
               </a:extLst>
             </p:cNvPr>
-            <p:cNvSpPr/>
+            <p:cNvPicPr>
+              <a:picLocks noChangeAspect="1" noChangeArrowheads="1"/>
+            </p:cNvPicPr>
             <p:nvPr/>
-          </p:nvSpPr>
-          <p:spPr>
-            <a:xfrm>
-              <a:off x="3033801" y="3025729"/>
-              <a:ext cx="147679" cy="648615"/>
-            </a:xfrm>
-            <a:custGeom>
-              <a:avLst/>
-              <a:gdLst>
-                <a:gd name="csX0" fmla="*/ 146791 w 147679"/>
-                <a:gd name="csY0" fmla="*/ 224308 h 648615"/>
-                <a:gd name="csX1" fmla="*/ 128689 w 147679"/>
-                <a:gd name="csY1" fmla="*/ 119256 h 648615"/>
-                <a:gd name="csX2" fmla="*/ 74310 w 147679"/>
-                <a:gd name="csY2" fmla="*/ 21720 h 648615"/>
-                <a:gd name="csX3" fmla="*/ 11254 w 147679"/>
-                <a:gd name="csY3" fmla="*/ 27020 h 648615"/>
-                <a:gd name="csX4" fmla="*/ 1197 w 147679"/>
-                <a:gd name="csY4" fmla="*/ 203670 h 648615"/>
-                <a:gd name="csX5" fmla="*/ 1764 w 147679"/>
-                <a:gd name="csY5" fmla="*/ 576859 h 648615"/>
-                <a:gd name="csX6" fmla="*/ 6665 w 147679"/>
-                <a:gd name="csY6" fmla="*/ 616574 h 648615"/>
-                <a:gd name="csX7" fmla="*/ 54173 w 147679"/>
-                <a:gd name="csY7" fmla="*/ 640460 h 648615"/>
-                <a:gd name="csX8" fmla="*/ 81839 w 147679"/>
-                <a:gd name="csY8" fmla="*/ 600905 h 648615"/>
-                <a:gd name="csX9" fmla="*/ 115523 w 147679"/>
-                <a:gd name="csY9" fmla="*/ 514847 h 648615"/>
-                <a:gd name="csX10" fmla="*/ 146843 w 147679"/>
-                <a:gd name="csY10" fmla="*/ 225174 h 648615"/>
-                <a:gd name="csX11" fmla="*/ 146791 w 147679"/>
-                <a:gd name="csY11" fmla="*/ 224308 h 648615"/>
-              </a:gdLst>
-              <a:ahLst/>
-              <a:cxnLst>
-                <a:cxn ang="0">
-                  <a:pos x="csX0" y="csY0"/>
-                </a:cxn>
-                <a:cxn ang="0">
-                  <a:pos x="csX1" y="csY1"/>
-                </a:cxn>
-                <a:cxn ang="0">
-                  <a:pos x="csX2" y="csY2"/>
-                </a:cxn>
-                <a:cxn ang="0">
-                  <a:pos x="csX3" y="csY3"/>
-                </a:cxn>
-                <a:cxn ang="0">
-                  <a:pos x="csX4" y="csY4"/>
-                </a:cxn>
-                <a:cxn ang="0">
-                  <a:pos x="csX5" y="csY5"/>
-                </a:cxn>
-                <a:cxn ang="0">
-                  <a:pos x="csX6" y="csY6"/>
-                </a:cxn>
-                <a:cxn ang="0">
-                  <a:pos x="csX7" y="csY7"/>
-                </a:cxn>
-                <a:cxn ang="0">
-                  <a:pos x="csX8" y="csY8"/>
-                </a:cxn>
-                <a:cxn ang="0">
-                  <a:pos x="csX9" y="csY9"/>
-                </a:cxn>
-                <a:cxn ang="0">
-                  <a:pos x="csX10" y="csY10"/>
-                </a:cxn>
-                <a:cxn ang="0">
-                  <a:pos x="csX11" y="csY11"/>
-                </a:cxn>
-              </a:cxnLst>
-              <a:rect l="l" t="t" r="r" b="b"/>
-              <a:pathLst>
-                <a:path w="147679" h="648615">
-                  <a:moveTo>
-                    <a:pt x="146791" y="224308"/>
-                  </a:moveTo>
-                  <a:cubicBezTo>
-                    <a:pt x="144760" y="188984"/>
-                    <a:pt x="139552" y="153282"/>
-                    <a:pt x="128689" y="119256"/>
-                  </a:cubicBezTo>
-                  <a:cubicBezTo>
-                    <a:pt x="117194" y="83235"/>
-                    <a:pt x="99209" y="48793"/>
-                    <a:pt x="74310" y="21720"/>
-                  </a:cubicBezTo>
-                  <a:cubicBezTo>
-                    <a:pt x="53654" y="-1473"/>
-                    <a:pt x="21104" y="-14544"/>
-                    <a:pt x="11254" y="27020"/>
-                  </a:cubicBezTo>
-                  <a:cubicBezTo>
-                    <a:pt x="1478" y="84733"/>
-                    <a:pt x="3007" y="145073"/>
-                    <a:pt x="1197" y="203670"/>
-                  </a:cubicBezTo>
-                  <a:cubicBezTo>
-                    <a:pt x="123" y="328187"/>
-                    <a:pt x="-1085" y="452705"/>
-                    <a:pt x="1764" y="576859"/>
-                  </a:cubicBezTo>
-                  <a:cubicBezTo>
-                    <a:pt x="2461" y="590376"/>
-                    <a:pt x="3526" y="604222"/>
-                    <a:pt x="6665" y="616574"/>
-                  </a:cubicBezTo>
-                  <a:cubicBezTo>
-                    <a:pt x="12302" y="642967"/>
-                    <a:pt x="32807" y="659341"/>
-                    <a:pt x="54173" y="640460"/>
-                  </a:cubicBezTo>
-                  <a:cubicBezTo>
-                    <a:pt x="66331" y="630173"/>
-                    <a:pt x="74708" y="615167"/>
-                    <a:pt x="81839" y="600905"/>
-                  </a:cubicBezTo>
-                  <a:cubicBezTo>
-                    <a:pt x="95248" y="573378"/>
-                    <a:pt x="106426" y="544431"/>
-                    <a:pt x="115523" y="514847"/>
-                  </a:cubicBezTo>
-                  <a:cubicBezTo>
-                    <a:pt x="143383" y="421580"/>
-                    <a:pt x="150350" y="321974"/>
-                    <a:pt x="146843" y="225174"/>
-                  </a:cubicBezTo>
-                  <a:lnTo>
-                    <a:pt x="146791" y="224308"/>
-                  </a:lnTo>
-                  <a:close/>
-                </a:path>
-              </a:pathLst>
-            </a:custGeom>
-            <a:solidFill>
-              <a:srgbClr val="EFDAC9">
-                <a:alpha val="69804"/>
-              </a:srgbClr>
-            </a:solidFill>
-            <a:ln w="4319" cap="flat">
-              <a:noFill/>
-              <a:prstDash val="solid"/>
-              <a:miter/>
-            </a:ln>
-          </p:spPr>
-          <p:txBody>
-            <a:bodyPr/>
-            <a:lstStyle/>
-            <a:p>
-              <a:endParaRPr lang="en-US" sz="2000"/>
-            </a:p>
-          </p:txBody>
-        </p:sp>
-        <p:sp>
-          <p:nvSpPr>
-            <p:cNvPr id="19" name="Freeform: Shape 18">
+          </p:nvPicPr>
+          <p:blipFill>
+            <a:blip r:embed="rId2">
               <a:extLst>
-                <a:ext uri="{FF2B5EF4-FFF2-40B4-BE49-F238E27FC236}">
-                  <a16:creationId xmlns:a16="http://schemas.microsoft.com/office/drawing/2014/main" id="{9142EB24-BE30-38ED-8E65-5AF33AA33713}"/>
+                <a:ext uri="{28A0092B-C50C-407E-A947-70E740481C1C}">
+                  <a14:useLocalDpi xmlns:a14="http://schemas.microsoft.com/office/drawing/2010/main" val="0"/>
                 </a:ext>
               </a:extLst>
-            </p:cNvPr>
-            <p:cNvSpPr/>
-            <p:nvPr/>
-          </p:nvSpPr>
-          <p:spPr>
+            </a:blip>
+            <a:srcRect/>
+            <a:stretch>
+              <a:fillRect/>
+            </a:stretch>
+          </p:blipFill>
+          <p:spPr bwMode="auto">
             <a:xfrm>
-              <a:off x="3034674" y="3703333"/>
-              <a:ext cx="70325" cy="124917"/>
+              <a:off x="3399757" y="689597"/>
+              <a:ext cx="809433" cy="809433"/>
             </a:xfrm>
-            <a:custGeom>
+            <a:prstGeom prst="rect">
               <a:avLst/>
-              <a:gdLst>
-                <a:gd name="csX0" fmla="*/ 52772 w 70325"/>
-                <a:gd name="csY0" fmla="*/ 4195 h 124917"/>
-                <a:gd name="csX1" fmla="*/ 3320 w 70325"/>
-                <a:gd name="csY1" fmla="*/ 35454 h 124917"/>
-                <a:gd name="csX2" fmla="*/ 13274 w 70325"/>
-                <a:gd name="csY2" fmla="*/ 111935 h 124917"/>
-                <a:gd name="csX3" fmla="*/ 34233 w 70325"/>
-                <a:gd name="csY3" fmla="*/ 124889 h 124917"/>
-                <a:gd name="csX4" fmla="*/ 70294 w 70325"/>
-                <a:gd name="csY4" fmla="*/ 48733 h 124917"/>
-                <a:gd name="csX5" fmla="*/ 52772 w 70325"/>
-                <a:gd name="csY5" fmla="*/ 4195 h 124917"/>
-              </a:gdLst>
-              <a:ahLst/>
-              <a:cxnLst>
-                <a:cxn ang="0">
-                  <a:pos x="csX0" y="csY0"/>
-                </a:cxn>
-                <a:cxn ang="0">
-                  <a:pos x="csX1" y="csY1"/>
-                </a:cxn>
-                <a:cxn ang="0">
-                  <a:pos x="csX2" y="csY2"/>
-                </a:cxn>
-                <a:cxn ang="0">
-                  <a:pos x="csX3" y="csY3"/>
-                </a:cxn>
-                <a:cxn ang="0">
-                  <a:pos x="csX4" y="csY4"/>
-                </a:cxn>
-                <a:cxn ang="0">
-                  <a:pos x="csX5" y="csY5"/>
-                </a:cxn>
-              </a:cxnLst>
-              <a:rect l="l" t="t" r="r" b="b"/>
-              <a:pathLst>
-                <a:path w="70325" h="124917">
-                  <a:moveTo>
-                    <a:pt x="52772" y="4195"/>
-                  </a:moveTo>
-                  <a:cubicBezTo>
-                    <a:pt x="30705" y="-10301"/>
-                    <a:pt x="8957" y="15880"/>
-                    <a:pt x="3320" y="35454"/>
-                  </a:cubicBezTo>
-                  <a:cubicBezTo>
-                    <a:pt x="-3287" y="58396"/>
-                    <a:pt x="-66" y="91915"/>
-                    <a:pt x="13274" y="111935"/>
-                  </a:cubicBezTo>
-                  <a:cubicBezTo>
-                    <a:pt x="18041" y="119092"/>
-                    <a:pt x="25635" y="125392"/>
-                    <a:pt x="34233" y="124889"/>
-                  </a:cubicBezTo>
-                  <a:cubicBezTo>
-                    <a:pt x="64652" y="123093"/>
-                    <a:pt x="69714" y="71476"/>
-                    <a:pt x="70294" y="48733"/>
-                  </a:cubicBezTo>
-                  <a:cubicBezTo>
-                    <a:pt x="70701" y="32661"/>
-                    <a:pt x="67250" y="13711"/>
-                    <a:pt x="52772" y="4195"/>
-                  </a:cubicBezTo>
-                  <a:close/>
-                </a:path>
-              </a:pathLst>
-            </a:custGeom>
-            <a:solidFill>
-              <a:srgbClr val="EFDAC9">
-                <a:alpha val="69804"/>
-              </a:srgbClr>
-            </a:solidFill>
-            <a:ln w="4319" cap="flat">
-              <a:noFill/>
-              <a:prstDash val="solid"/>
-              <a:miter/>
-            </a:ln>
+            </a:prstGeom>
+            <a:noFill/>
+            <a:scene3d>
+              <a:camera prst="orthographicFront">
+                <a:rot lat="0" lon="1799990" rev="21299999"/>
+              </a:camera>
+              <a:lightRig rig="threePt" dir="t"/>
+            </a:scene3d>
+            <a:extLst>
+              <a:ext uri="{909E8E84-426E-40DD-AFC4-6F175D3DCCD1}">
+                <a14:hiddenFill xmlns:a14="http://schemas.microsoft.com/office/drawing/2010/main">
+                  <a:solidFill>
+                    <a:srgbClr val="FFFFFF"/>
+                  </a:solidFill>
+                </a14:hiddenFill>
+              </a:ext>
+            </a:extLst>
           </p:spPr>
-          <p:txBody>
-            <a:bodyPr/>
-            <a:lstStyle/>
-            <a:p>
-              <a:endParaRPr lang="en-US" sz="2000"/>
-            </a:p>
-          </p:txBody>
-        </p:sp>
+        </p:pic>
       </p:grpSp>
-      <p:pic>
-        <p:nvPicPr>
-          <p:cNvPr id="1026" name="Picture 2">
+      <p:sp>
+        <p:nvSpPr>
+          <p:cNvPr id="3" name="TextBox 2">
             <a:extLst>
               <a:ext uri="{FF2B5EF4-FFF2-40B4-BE49-F238E27FC236}">
-                <a16:creationId xmlns:a16="http://schemas.microsoft.com/office/drawing/2014/main" id="{152AB09A-3981-4A02-9E01-E7A7D792CD70}"/>
+                <a16:creationId xmlns:a16="http://schemas.microsoft.com/office/drawing/2014/main" id="{40CBB050-D946-1EB5-6735-CEF23C96FDC1}"/>
               </a:ext>
             </a:extLst>
           </p:cNvPr>
-          <p:cNvPicPr>
-            <a:picLocks noChangeAspect="1" noChangeArrowheads="1"/>
-          </p:cNvPicPr>
+          <p:cNvSpPr txBox="1"/>
           <p:nvPr/>
-        </p:nvPicPr>
-        <p:blipFill>
-          <a:blip r:embed="rId2">
-            <a:extLst>
-              <a:ext uri="{28A0092B-C50C-407E-A947-70E740481C1C}">
-                <a14:useLocalDpi xmlns:a14="http://schemas.microsoft.com/office/drawing/2010/main" val="0"/>
-              </a:ext>
-            </a:extLst>
-          </a:blip>
-          <a:srcRect/>
-          <a:stretch>
-            <a:fillRect/>
-          </a:stretch>
-        </p:blipFill>
-        <p:spPr bwMode="auto">
+        </p:nvSpPr>
+        <p:spPr>
           <a:xfrm>
-            <a:off x="3617645" y="689597"/>
-            <a:ext cx="809433" cy="809433"/>
+            <a:off x="1397162" y="298847"/>
+            <a:ext cx="4751301" cy="1231106"/>
           </a:xfrm>
           <a:prstGeom prst="rect">
             <a:avLst/>
           </a:prstGeom>
           <a:noFill/>
-          <a:scene3d>
-            <a:camera prst="orthographicFront">
-              <a:rot lat="0" lon="1799990" rev="21299999"/>
-            </a:camera>
-            <a:lightRig rig="threePt" dir="t"/>
-          </a:scene3d>
-          <a:extLst>
-            <a:ext uri="{909E8E84-426E-40DD-AFC4-6F175D3DCCD1}">
-              <a14:hiddenFill xmlns:a14="http://schemas.microsoft.com/office/drawing/2010/main">
+        </p:spPr>
+        <p:txBody>
+          <a:bodyPr wrap="none" lIns="0" tIns="0" rIns="0" bIns="0" rtlCol="0">
+            <a:spAutoFit/>
+          </a:bodyPr>
+          <a:lstStyle/>
+          <a:p>
+            <a:pPr algn="ctr"/>
+            <a:r>
+              <a:rPr lang="en-US" sz="8000">
                 <a:solidFill>
-                  <a:srgbClr val="FFFFFF"/>
+                  <a:sysClr val="windowText" lastClr="000000"/>
                 </a:solidFill>
-              </a14:hiddenFill>
-            </a:ext>
-          </a:extLst>
+                <a:latin typeface="#9Slide03 SFU Toledo Bold" panose="00000700000000000000" pitchFamily="2" charset="0"/>
+              </a:rPr>
+              <a:t>ChatCargo</a:t>
+            </a:r>
+          </a:p>
+        </p:txBody>
+      </p:sp>
+      <p:sp>
+        <p:nvSpPr>
+          <p:cNvPr id="7" name="TextBox 6">
+            <a:extLst>
+              <a:ext uri="{FF2B5EF4-FFF2-40B4-BE49-F238E27FC236}">
+                <a16:creationId xmlns:a16="http://schemas.microsoft.com/office/drawing/2014/main" id="{F333C080-0532-F3B1-3125-C2CD79F849D3}"/>
+              </a:ext>
+            </a:extLst>
+          </p:cNvPr>
+          <p:cNvSpPr txBox="1"/>
+          <p:nvPr/>
+        </p:nvSpPr>
+        <p:spPr>
+          <a:xfrm>
+            <a:off x="8278122" y="298847"/>
+            <a:ext cx="2516715" cy="1231106"/>
+          </a:xfrm>
+          <a:prstGeom prst="rect">
+            <a:avLst/>
+          </a:prstGeom>
+          <a:noFill/>
         </p:spPr>
-      </p:pic>
+        <p:txBody>
+          <a:bodyPr wrap="none" lIns="0" tIns="0" rIns="0" bIns="0" rtlCol="0">
+            <a:spAutoFit/>
+          </a:bodyPr>
+          <a:lstStyle/>
+          <a:p>
+            <a:r>
+              <a:rPr lang="en-US" sz="8000">
+                <a:solidFill>
+                  <a:sysClr val="windowText" lastClr="000000"/>
+                </a:solidFill>
+                <a:latin typeface="#9Slide03 SFU Toledo Bold" panose="00000700000000000000" pitchFamily="2" charset="0"/>
+              </a:rPr>
+              <a:t>Skills</a:t>
+            </a:r>
+          </a:p>
+        </p:txBody>
+      </p:sp>
+      <p:sp>
+        <p:nvSpPr>
+          <p:cNvPr id="21" name="TextBox 20">
+            <a:extLst>
+              <a:ext uri="{FF2B5EF4-FFF2-40B4-BE49-F238E27FC236}">
+                <a16:creationId xmlns:a16="http://schemas.microsoft.com/office/drawing/2014/main" id="{0411BF74-7A0D-28A6-F130-9BF8D825EEBA}"/>
+              </a:ext>
+            </a:extLst>
+          </p:cNvPr>
+          <p:cNvSpPr txBox="1"/>
+          <p:nvPr/>
+        </p:nvSpPr>
+        <p:spPr>
+          <a:xfrm>
+            <a:off x="10763539" y="1512168"/>
+            <a:ext cx="1351332" cy="246221"/>
+          </a:xfrm>
+          <a:prstGeom prst="rect">
+            <a:avLst/>
+          </a:prstGeom>
+          <a:noFill/>
+        </p:spPr>
+        <p:txBody>
+          <a:bodyPr wrap="none" lIns="0" tIns="0" rIns="0" bIns="0" rtlCol="0">
+            <a:spAutoFit/>
+          </a:bodyPr>
+          <a:lstStyle/>
+          <a:p>
+            <a:pPr algn="r"/>
+            <a:r>
+              <a:rPr lang="en-US" sz="1600">
+                <a:solidFill>
+                  <a:schemeClr val="bg1">
+                    <a:lumMod val="50000"/>
+                  </a:schemeClr>
+                </a:solidFill>
+                <a:latin typeface="#9Slide03 SFU Toledo Bold" panose="00000700000000000000" pitchFamily="2" charset="0"/>
+              </a:rPr>
+              <a:t>by the-khiem7</a:t>
+            </a:r>
+          </a:p>
+        </p:txBody>
+      </p:sp>
     </p:spTree>
     <p:extLst>
       <p:ext uri="{BB962C8B-B14F-4D97-AF65-F5344CB8AC3E}">
-        <p14:creationId xmlns:p14="http://schemas.microsoft.com/office/powerpoint/2010/main" val="2817079516"/>
+        <p14:creationId xmlns:p14="http://schemas.microsoft.com/office/powerpoint/2010/main" val="1977752457"/>
       </p:ext>
     </p:extLst>
   </p:cSld>

</xml_diff>